<commit_message>
feat: add information about ephemeral pods
</commit_message>
<xml_diff>
--- a/kubernetes/06_troubleshooting.pptx
+++ b/kubernetes/06_troubleshooting.pptx
@@ -5,10 +5,10 @@
     <p:sldMasterId id="2147483733" r:id="rId1"/>
   </p:sldMasterIdLst>
   <p:notesMasterIdLst>
-    <p:notesMasterId r:id="rId13"/>
+    <p:notesMasterId r:id="rId14"/>
   </p:notesMasterIdLst>
   <p:handoutMasterIdLst>
-    <p:handoutMasterId r:id="rId14"/>
+    <p:handoutMasterId r:id="rId15"/>
   </p:handoutMasterIdLst>
   <p:sldIdLst>
     <p:sldId id="433" r:id="rId2"/>
@@ -17,11 +17,12 @@
     <p:sldId id="453" r:id="rId5"/>
     <p:sldId id="455" r:id="rId6"/>
     <p:sldId id="457" r:id="rId7"/>
-    <p:sldId id="459" r:id="rId8"/>
-    <p:sldId id="458" r:id="rId9"/>
-    <p:sldId id="456" r:id="rId10"/>
-    <p:sldId id="460" r:id="rId11"/>
-    <p:sldId id="265" r:id="rId12"/>
+    <p:sldId id="461" r:id="rId8"/>
+    <p:sldId id="459" r:id="rId9"/>
+    <p:sldId id="458" r:id="rId10"/>
+    <p:sldId id="456" r:id="rId11"/>
+    <p:sldId id="460" r:id="rId12"/>
+    <p:sldId id="265" r:id="rId13"/>
   </p:sldIdLst>
   <p:sldSz cx="12195175" cy="6858000"/>
   <p:notesSz cx="6858000" cy="9144000"/>
@@ -654,6 +655,171 @@
           <a:bodyPr/>
           <a:lstStyle/>
           <a:p>
+            <a:r>
+              <a:rPr lang="en-US" dirty="0"/>
+              <a:t>There are various reasons why a service may not be working properly. </a:t>
+            </a:r>
+            <a:r>
+              <a:rPr lang="en-US" dirty="0" err="1"/>
+              <a:t>Kube-dns</a:t>
+            </a:r>
+            <a:r>
+              <a:rPr lang="en-US" dirty="0"/>
+              <a:t> &amp; </a:t>
+            </a:r>
+            <a:r>
+              <a:rPr lang="en-US" dirty="0" err="1"/>
+              <a:t>kube</a:t>
+            </a:r>
+            <a:r>
+              <a:rPr lang="en-US" dirty="0"/>
+              <a:t>-proxy might have issues but most likely the issues during a training are user-specific.</a:t>
+            </a:r>
+          </a:p>
+          <a:p>
+            <a:r>
+              <a:rPr lang="en-US" dirty="0"/>
+              <a:t>So here are a few ideas how to debug a service based on the “describe command”</a:t>
+            </a:r>
+          </a:p>
+          <a:p>
+            <a:endParaRPr lang="en-US" dirty="0"/>
+          </a:p>
+          <a:p>
+            <a:pPr marL="342900" indent="-342900">
+              <a:buAutoNum type="arabicParenR"/>
+            </a:pPr>
+            <a:r>
+              <a:rPr lang="en-US" dirty="0"/>
+              <a:t>Are you using the correct set of labels (</a:t>
+            </a:r>
+            <a:r>
+              <a:rPr lang="en-US" dirty="0" err="1"/>
+              <a:t>key:value</a:t>
+            </a:r>
+            <a:r>
+              <a:rPr lang="en-US" dirty="0"/>
+              <a:t> pairs) to select pods that should be managed by the service?</a:t>
+            </a:r>
+          </a:p>
+          <a:p>
+            <a:pPr marL="180000" lvl="1" indent="0">
+              <a:buNone/>
+            </a:pPr>
+            <a:r>
+              <a:rPr lang="en-US" dirty="0"/>
+              <a:t>    Test with “</a:t>
+            </a:r>
+            <a:r>
+              <a:rPr lang="en-US" dirty="0" err="1"/>
+              <a:t>kubectl</a:t>
+            </a:r>
+            <a:r>
+              <a:rPr lang="en-US" dirty="0"/>
+              <a:t> get pods –l &lt;key&gt;=&lt;value&gt;” as described in the selector of the service.</a:t>
+            </a:r>
+          </a:p>
+          <a:p>
+            <a:pPr marL="342900" indent="-342900">
+              <a:buAutoNum type="arabicParenR"/>
+            </a:pPr>
+            <a:r>
+              <a:rPr lang="en-US" dirty="0"/>
+              <a:t>Are you targeting the correct port? The target port is the port specified in the pod spec.</a:t>
+            </a:r>
+          </a:p>
+          <a:p>
+            <a:pPr marL="342900" indent="-342900">
+              <a:buAutoNum type="arabicParenR"/>
+            </a:pPr>
+            <a:r>
+              <a:rPr lang="en-US" dirty="0"/>
+              <a:t>Are there any pods available? The “Endpoints” part of the description lists all the IP addresses of the pods identified by the label. Run the query with from step 1 with “-o wide” and check for the IP addresses. If there are no endpoints listed, either the label/selector part is wrong or there are simply no pods (e.g. because someone deleted the deployment)</a:t>
+            </a:r>
+          </a:p>
+        </p:txBody>
+      </p:sp>
+      <p:sp>
+        <p:nvSpPr>
+          <p:cNvPr id="4" name="Slide Number Placeholder 3"/>
+          <p:cNvSpPr>
+            <a:spLocks noGrp="1"/>
+          </p:cNvSpPr>
+          <p:nvPr>
+            <p:ph type="sldNum" sz="quarter" idx="10"/>
+          </p:nvPr>
+        </p:nvSpPr>
+        <p:spPr/>
+        <p:txBody>
+          <a:bodyPr/>
+          <a:lstStyle/>
+          <a:p>
+            <a:fld id="{7D8C2C35-2B8A-446E-BEC0-FD36716C29AC}" type="slidenum">
+              <a:rPr lang="de-DE" smtClean="0"/>
+              <a:pPr/>
+              <a:t>10</a:t>
+            </a:fld>
+            <a:endParaRPr lang="de-DE" dirty="0"/>
+          </a:p>
+        </p:txBody>
+      </p:sp>
+    </p:spTree>
+    <p:extLst>
+      <p:ext uri="{BB962C8B-B14F-4D97-AF65-F5344CB8AC3E}">
+        <p14:creationId xmlns:p14="http://schemas.microsoft.com/office/powerpoint/2010/main" val="1210700300"/>
+      </p:ext>
+    </p:extLst>
+  </p:cSld>
+  <p:clrMapOvr>
+    <a:masterClrMapping/>
+  </p:clrMapOvr>
+</p:notes>
+</file>
+
+<file path=ppt/notesSlides/notesSlide11.xml><?xml version="1.0" encoding="utf-8"?>
+<p:notes xmlns:a="http://schemas.openxmlformats.org/drawingml/2006/main" xmlns:r="http://schemas.openxmlformats.org/officeDocument/2006/relationships" xmlns:p="http://schemas.openxmlformats.org/presentationml/2006/main">
+  <p:cSld>
+    <p:spTree>
+      <p:nvGrpSpPr>
+        <p:cNvPr id="1" name=""/>
+        <p:cNvGrpSpPr/>
+        <p:nvPr/>
+      </p:nvGrpSpPr>
+      <p:grpSpPr>
+        <a:xfrm>
+          <a:off x="0" y="0"/>
+          <a:ext cx="0" cy="0"/>
+          <a:chOff x="0" y="0"/>
+          <a:chExt cx="0" cy="0"/>
+        </a:xfrm>
+      </p:grpSpPr>
+      <p:sp>
+        <p:nvSpPr>
+          <p:cNvPr id="2" name="Slide Image Placeholder 1"/>
+          <p:cNvSpPr>
+            <a:spLocks noGrp="1" noRot="1" noChangeAspect="1"/>
+          </p:cNvSpPr>
+          <p:nvPr>
+            <p:ph type="sldImg"/>
+          </p:nvPr>
+        </p:nvSpPr>
+        <p:spPr/>
+      </p:sp>
+      <p:sp>
+        <p:nvSpPr>
+          <p:cNvPr id="3" name="Notes Placeholder 2"/>
+          <p:cNvSpPr>
+            <a:spLocks noGrp="1"/>
+          </p:cNvSpPr>
+          <p:nvPr>
+            <p:ph type="body" idx="1"/>
+          </p:nvPr>
+        </p:nvSpPr>
+        <p:spPr/>
+        <p:txBody>
+          <a:bodyPr/>
+          <a:lstStyle/>
+          <a:p>
             <a:pPr marL="285750" marR="0" lvl="0" indent="-285750" algn="l" defTabSz="1088776" rtl="0" eaLnBrk="1" fontAlgn="auto" latinLnBrk="0" hangingPunct="1">
               <a:lnSpc>
                 <a:spcPct val="100000"/>
@@ -1027,7 +1193,7 @@
             <a:fld id="{7D8C2C35-2B8A-446E-BEC0-FD36716C29AC}" type="slidenum">
               <a:rPr lang="de-DE" smtClean="0"/>
               <a:pPr/>
-              <a:t>10</a:t>
+              <a:t>11</a:t>
             </a:fld>
             <a:endParaRPr lang="de-DE" dirty="0"/>
           </a:p>
@@ -1046,7 +1212,7 @@
 </p:notes>
 </file>
 
-<file path=ppt/notesSlides/notesSlide11.xml><?xml version="1.0" encoding="utf-8"?>
+<file path=ppt/notesSlides/notesSlide12.xml><?xml version="1.0" encoding="utf-8"?>
 <p:notes xmlns:a="http://schemas.openxmlformats.org/drawingml/2006/main" xmlns:r="http://schemas.openxmlformats.org/officeDocument/2006/relationships" xmlns:p="http://schemas.openxmlformats.org/presentationml/2006/main">
   <p:cSld>
     <p:spTree>
@@ -1081,7 +1247,7 @@
             <a:fld id="{7D8C2C35-2B8A-446E-BEC0-FD36716C29AC}" type="slidenum">
               <a:rPr lang="en-US" smtClean="0"/>
               <a:pPr/>
-              <a:t>11</a:t>
+              <a:t>12</a:t>
             </a:fld>
             <a:endParaRPr lang="en-US" dirty="0"/>
           </a:p>
@@ -1186,7 +1352,7 @@
           <a:p>
             <a:r>
               <a:rPr lang="en-US" dirty="0"/>
-              <a:t>Pretty much as with software operations, in the game exploding kittens, you want to be the last man/women standing. This slide deck is about troubleshooting pods and services.</a:t>
+              <a:t>Pretty much as with software operations, in the game exploding kittens, you want to be the last one standing despite all the obstacles thrown into your way. This slide deck is about troubleshooting pods and services.</a:t>
             </a:r>
           </a:p>
         </p:txBody>
@@ -1431,7 +1597,7 @@
           <a:p>
             <a:r>
               <a:rPr lang="en-US" dirty="0"/>
-              <a:t>If you face an error there are a few thing you can always check. Debugging relevant information is store in the logs of a pod but also hidden in the events associated with the resource your currently looking at.</a:t>
+              <a:t>If you face an error there are a few thing you can always check. Debugging relevant information is stored in the logs of a pod but also hidden in the events associated with the resource your currently looking at.</a:t>
             </a:r>
           </a:p>
         </p:txBody>
@@ -1751,431 +1917,133 @@
           <a:bodyPr/>
           <a:lstStyle/>
           <a:p>
-            <a:pPr marL="285750" marR="0" lvl="0" indent="-285750" algn="l" defTabSz="1088776" rtl="0" eaLnBrk="1" fontAlgn="auto" latinLnBrk="0" hangingPunct="1">
-              <a:lnSpc>
-                <a:spcPct val="100000"/>
-              </a:lnSpc>
-              <a:spcBef>
-                <a:spcPts val="0"/>
-              </a:spcBef>
-              <a:spcAft>
-                <a:spcPts val="0"/>
-              </a:spcAft>
-              <a:buClrTx/>
-              <a:buSzTx/>
+            <a:r>
+              <a:rPr lang="en-US" dirty="0"/>
+              <a:t>The following vehicles may help if a Pod must be debugged that contains containers with no shell (like </a:t>
+            </a:r>
+            <a:r>
+              <a:rPr lang="en-US" dirty="0" err="1"/>
+              <a:t>distroless</a:t>
+            </a:r>
+            <a:r>
+              <a:rPr lang="en-US" dirty="0"/>
+              <a:t> images) or other debugging tools (such as </a:t>
+            </a:r>
+            <a:r>
+              <a:rPr lang="en-US" dirty="0" err="1"/>
+              <a:t>nslookup</a:t>
+            </a:r>
+            <a:r>
+              <a:rPr lang="en-US" dirty="0"/>
+              <a:t>, ping </a:t>
+            </a:r>
+            <a:r>
+              <a:rPr lang="en-US"/>
+              <a:t>or debuggers)</a:t>
+            </a:r>
+            <a:endParaRPr lang="en-US" dirty="0"/>
+          </a:p>
+          <a:p>
+            <a:endParaRPr lang="en-US" dirty="0"/>
+          </a:p>
+          <a:p>
+            <a:r>
+              <a:rPr lang="en-US" dirty="0"/>
+              <a:t>Ephemeral Containers</a:t>
+            </a:r>
+          </a:p>
+          <a:p>
+            <a:pPr marL="285750" indent="-285750">
               <a:buFontTx/>
               <a:buChar char="-"/>
-              <a:tabLst/>
-              <a:defRPr/>
             </a:pPr>
             <a:r>
-              <a:rPr lang="en-US" baseline="0" dirty="0"/>
-              <a:t>Use the </a:t>
-            </a:r>
-            <a:r>
-              <a:rPr lang="en-US" baseline="0" dirty="0" err="1"/>
-              <a:t>crashloop</a:t>
-            </a:r>
-            <a:r>
-              <a:rPr lang="en-US" baseline="0" dirty="0"/>
-              <a:t> and </a:t>
-            </a:r>
-            <a:r>
-              <a:rPr lang="en-US" baseline="0" dirty="0" err="1"/>
-              <a:t>app_failure</a:t>
-            </a:r>
-            <a:r>
-              <a:rPr lang="en-US" baseline="0" dirty="0"/>
-              <a:t> demos </a:t>
-            </a:r>
-          </a:p>
-          <a:p>
-            <a:pPr marL="285750" marR="0" lvl="0" indent="-285750" algn="l" defTabSz="1088776" rtl="0" eaLnBrk="1" fontAlgn="auto" latinLnBrk="0" hangingPunct="1">
-              <a:lnSpc>
-                <a:spcPct val="100000"/>
-              </a:lnSpc>
-              <a:spcBef>
-                <a:spcPts val="0"/>
-              </a:spcBef>
-              <a:spcAft>
-                <a:spcPts val="0"/>
-              </a:spcAft>
-              <a:buClrTx/>
-              <a:buSzTx/>
+              <a:rPr lang="en-US" dirty="0"/>
+              <a:t>Allow you to add a container to a running Pod and connect to it</a:t>
+            </a:r>
+          </a:p>
+          <a:p>
+            <a:pPr marL="285750" indent="-285750">
               <a:buFontTx/>
               <a:buChar char="-"/>
-              <a:tabLst/>
-              <a:defRPr/>
             </a:pPr>
             <a:r>
-              <a:rPr lang="en-US" baseline="0" dirty="0" err="1"/>
-              <a:t>Crashloop</a:t>
-            </a:r>
-            <a:r>
-              <a:rPr lang="en-US" baseline="0" dirty="0"/>
-              <a:t>:</a:t>
-            </a:r>
-          </a:p>
-          <a:p>
-            <a:pPr marL="465750" marR="0" lvl="1" indent="-285750" algn="l" defTabSz="1088776" rtl="0" eaLnBrk="1" fontAlgn="auto" latinLnBrk="0" hangingPunct="1">
-              <a:lnSpc>
-                <a:spcPct val="100000"/>
-              </a:lnSpc>
-              <a:spcBef>
-                <a:spcPts val="0"/>
-              </a:spcBef>
-              <a:spcAft>
-                <a:spcPts val="0"/>
-              </a:spcAft>
-              <a:buClrTx/>
-              <a:buSzTx/>
+              <a:rPr lang="en-US" dirty="0"/>
+              <a:t>Enables to debug the Pod, e.g. connectivity</a:t>
+            </a:r>
+          </a:p>
+          <a:p>
+            <a:pPr marL="285750" indent="-285750">
               <a:buFontTx/>
               <a:buChar char="-"/>
-              <a:tabLst/>
-              <a:defRPr/>
             </a:pPr>
             <a:r>
-              <a:rPr lang="en-US" baseline="0" dirty="0"/>
-              <a:t>Show the </a:t>
-            </a:r>
-            <a:r>
-              <a:rPr lang="en-US" baseline="0" dirty="0" err="1"/>
-              <a:t>yaml</a:t>
-            </a:r>
-            <a:r>
-              <a:rPr lang="en-US" baseline="0" dirty="0"/>
-              <a:t> file</a:t>
-            </a:r>
-          </a:p>
-          <a:p>
-            <a:pPr marL="465750" marR="0" lvl="1" indent="-285750" algn="l" defTabSz="1088776" rtl="0" eaLnBrk="1" fontAlgn="auto" latinLnBrk="0" hangingPunct="1">
-              <a:lnSpc>
-                <a:spcPct val="100000"/>
-              </a:lnSpc>
-              <a:spcBef>
-                <a:spcPts val="0"/>
-              </a:spcBef>
-              <a:spcAft>
-                <a:spcPts val="0"/>
-              </a:spcAft>
-              <a:buClrTx/>
-              <a:buSzTx/>
+              <a:rPr lang="en-US" dirty="0"/>
+              <a:t>Can share the process namespace of another container in the Pod so you can even attach a debugger to a running process</a:t>
+            </a:r>
+          </a:p>
+          <a:p>
+            <a:pPr marL="285750" indent="-285750">
               <a:buFontTx/>
               <a:buChar char="-"/>
-              <a:tabLst/>
-              <a:defRPr/>
             </a:pPr>
             <a:r>
-              <a:rPr lang="en-US" baseline="0" dirty="0"/>
-              <a:t>Run the pod and show the restart counter &amp; error message with </a:t>
-            </a:r>
-            <a:r>
-              <a:rPr lang="en-US" baseline="0" dirty="0" err="1"/>
-              <a:t>kubectl</a:t>
-            </a:r>
-            <a:r>
-              <a:rPr lang="en-US" baseline="0" dirty="0"/>
-              <a:t> get pods</a:t>
-            </a:r>
-          </a:p>
-          <a:p>
-            <a:pPr marL="465750" marR="0" lvl="1" indent="-285750" algn="l" defTabSz="1088776" rtl="0" eaLnBrk="1" fontAlgn="auto" latinLnBrk="0" hangingPunct="1">
-              <a:lnSpc>
-                <a:spcPct val="100000"/>
-              </a:lnSpc>
-              <a:spcBef>
-                <a:spcPts val="0"/>
-              </a:spcBef>
-              <a:spcAft>
-                <a:spcPts val="0"/>
-              </a:spcAft>
-              <a:buClrTx/>
-              <a:buSzTx/>
+              <a:rPr lang="en-US" dirty="0"/>
+              <a:t>Cannot see the filesystem of other containers in the Pod</a:t>
+            </a:r>
+          </a:p>
+          <a:p>
+            <a:pPr marL="285750" indent="-285750">
               <a:buFontTx/>
               <a:buChar char="-"/>
-              <a:tabLst/>
-              <a:defRPr/>
             </a:pPr>
-            <a:r>
-              <a:rPr lang="en-US" baseline="0" dirty="0"/>
-              <a:t>Show the logs of the pod </a:t>
-            </a:r>
-            <a:r>
-              <a:rPr lang="en-US" baseline="0" dirty="0">
-                <a:sym typeface="Wingdings" panose="05000000000000000000" pitchFamily="2" charset="2"/>
-              </a:rPr>
-              <a:t> expected output: /bin/</a:t>
-            </a:r>
-            <a:r>
-              <a:rPr lang="en-US" baseline="0" dirty="0" err="1">
-                <a:sym typeface="Wingdings" panose="05000000000000000000" pitchFamily="2" charset="2"/>
-              </a:rPr>
-              <a:t>sh</a:t>
-            </a:r>
-            <a:r>
-              <a:rPr lang="en-US" baseline="0" dirty="0">
-                <a:sym typeface="Wingdings" panose="05000000000000000000" pitchFamily="2" charset="2"/>
-              </a:rPr>
-              <a:t>: no-such-</a:t>
-            </a:r>
-            <a:r>
-              <a:rPr lang="en-US" baseline="0" dirty="0" err="1">
-                <a:sym typeface="Wingdings" panose="05000000000000000000" pitchFamily="2" charset="2"/>
-              </a:rPr>
-              <a:t>cmd</a:t>
-            </a:r>
-            <a:r>
-              <a:rPr lang="en-US" baseline="0" dirty="0">
-                <a:sym typeface="Wingdings" panose="05000000000000000000" pitchFamily="2" charset="2"/>
-              </a:rPr>
-              <a:t>: not found</a:t>
-            </a:r>
-            <a:endParaRPr lang="en-US" baseline="0" dirty="0"/>
-          </a:p>
-          <a:p>
-            <a:pPr marL="285750" marR="0" lvl="0" indent="-285750" algn="l" defTabSz="1088776" rtl="0" eaLnBrk="1" fontAlgn="auto" latinLnBrk="0" hangingPunct="1">
-              <a:lnSpc>
-                <a:spcPct val="100000"/>
-              </a:lnSpc>
-              <a:spcBef>
-                <a:spcPts val="0"/>
-              </a:spcBef>
-              <a:spcAft>
-                <a:spcPts val="0"/>
-              </a:spcAft>
-              <a:buClrTx/>
-              <a:buSzTx/>
+            <a:endParaRPr lang="en-US" dirty="0"/>
+          </a:p>
+          <a:p>
+            <a:pPr marL="0" indent="0">
+              <a:buFontTx/>
+              <a:buNone/>
+            </a:pPr>
+            <a:r>
+              <a:rPr lang="en-US" dirty="0"/>
+              <a:t>Copying of Pods for debugging</a:t>
+            </a:r>
+          </a:p>
+          <a:p>
+            <a:pPr marL="285750" indent="-285750">
               <a:buFontTx/>
               <a:buChar char="-"/>
-              <a:tabLst/>
-              <a:defRPr/>
             </a:pPr>
             <a:r>
-              <a:rPr lang="en-US" baseline="0" dirty="0"/>
-              <a:t>App failure:</a:t>
-            </a:r>
-          </a:p>
-          <a:p>
-            <a:pPr marL="465750" marR="0" lvl="1" indent="-285750" algn="l" defTabSz="1088776" rtl="0" eaLnBrk="1" fontAlgn="auto" latinLnBrk="0" hangingPunct="1">
-              <a:lnSpc>
-                <a:spcPct val="100000"/>
-              </a:lnSpc>
-              <a:spcBef>
-                <a:spcPts val="0"/>
-              </a:spcBef>
-              <a:spcAft>
-                <a:spcPts val="0"/>
-              </a:spcAft>
-              <a:buClrTx/>
-              <a:buSzTx/>
+              <a:rPr lang="en-US" dirty="0"/>
+              <a:t>Creates a duplicate of an existing Pod</a:t>
+            </a:r>
+          </a:p>
+          <a:p>
+            <a:pPr marL="285750" indent="-285750">
               <a:buFontTx/>
               <a:buChar char="-"/>
-              <a:tabLst/>
-              <a:defRPr/>
             </a:pPr>
             <a:r>
-              <a:rPr lang="en-US" baseline="0" dirty="0"/>
-              <a:t>Show the </a:t>
-            </a:r>
-            <a:r>
-              <a:rPr lang="en-US" baseline="0" dirty="0" err="1"/>
-              <a:t>yaml</a:t>
-            </a:r>
-            <a:r>
-              <a:rPr lang="en-US" baseline="0" dirty="0"/>
-              <a:t> file</a:t>
-            </a:r>
-          </a:p>
-          <a:p>
-            <a:pPr marL="465750" marR="0" lvl="1" indent="-285750" algn="l" defTabSz="1088776" rtl="0" eaLnBrk="1" fontAlgn="auto" latinLnBrk="0" hangingPunct="1">
-              <a:lnSpc>
-                <a:spcPct val="100000"/>
-              </a:lnSpc>
-              <a:spcBef>
-                <a:spcPts val="0"/>
-              </a:spcBef>
-              <a:spcAft>
-                <a:spcPts val="0"/>
-              </a:spcAft>
-              <a:buClrTx/>
-              <a:buSzTx/>
+              <a:rPr lang="en-US" dirty="0"/>
+              <a:t>Adds a debugging container to it which can share the process namespace with the other container in the Pod</a:t>
+            </a:r>
+          </a:p>
+          <a:p>
+            <a:pPr marL="285750" indent="-285750">
               <a:buFontTx/>
               <a:buChar char="-"/>
-              <a:tabLst/>
-              <a:defRPr/>
             </a:pPr>
-            <a:r>
-              <a:rPr lang="en-US" baseline="0" dirty="0"/>
-              <a:t>Start the pod and show it is running</a:t>
-            </a:r>
-          </a:p>
-          <a:p>
-            <a:pPr marL="465750" marR="0" lvl="1" indent="-285750" algn="l" defTabSz="1088776" rtl="0" eaLnBrk="1" fontAlgn="auto" latinLnBrk="0" hangingPunct="1">
-              <a:lnSpc>
-                <a:spcPct val="100000"/>
-              </a:lnSpc>
-              <a:spcBef>
-                <a:spcPts val="0"/>
-              </a:spcBef>
-              <a:spcAft>
-                <a:spcPts val="0"/>
-              </a:spcAft>
-              <a:buClrTx/>
-              <a:buSzTx/>
-              <a:buFontTx/>
-              <a:buChar char="-"/>
-              <a:tabLst/>
-              <a:defRPr/>
-            </a:pPr>
-            <a:r>
-              <a:rPr lang="en-US" baseline="0" dirty="0"/>
-              <a:t>Use port forward to get to the index.html page (</a:t>
-            </a:r>
-            <a:r>
-              <a:rPr lang="en-US" baseline="0" dirty="0" err="1"/>
-              <a:t>kubectl</a:t>
-            </a:r>
-            <a:r>
-              <a:rPr lang="en-US" baseline="0" dirty="0"/>
-              <a:t> port-forward app-failure 8080:80)</a:t>
-            </a:r>
-          </a:p>
-          <a:p>
-            <a:pPr marL="465750" marR="0" lvl="1" indent="-285750" algn="l" defTabSz="1088776" rtl="0" eaLnBrk="1" fontAlgn="auto" latinLnBrk="0" hangingPunct="1">
-              <a:lnSpc>
-                <a:spcPct val="100000"/>
-              </a:lnSpc>
-              <a:spcBef>
-                <a:spcPts val="0"/>
-              </a:spcBef>
-              <a:spcAft>
-                <a:spcPts val="0"/>
-              </a:spcAft>
-              <a:buClrTx/>
-              <a:buSzTx/>
-              <a:buFontTx/>
-              <a:buChar char="-"/>
-              <a:tabLst/>
-              <a:defRPr/>
-            </a:pPr>
-            <a:r>
-              <a:rPr lang="en-US" baseline="0" dirty="0"/>
-              <a:t>Show the error message with </a:t>
-            </a:r>
-            <a:r>
-              <a:rPr lang="en-US" baseline="0" dirty="0" err="1"/>
-              <a:t>kubectl</a:t>
-            </a:r>
-            <a:r>
-              <a:rPr lang="en-US" baseline="0" dirty="0"/>
-              <a:t> logs … &amp; exec into the pod. Show the directory without the index.html file</a:t>
-            </a:r>
-          </a:p>
-          <a:p>
-            <a:pPr marL="465750" marR="0" lvl="1" indent="-285750" algn="l" defTabSz="1088776" rtl="0" eaLnBrk="1" fontAlgn="auto" latinLnBrk="0" hangingPunct="1">
-              <a:lnSpc>
-                <a:spcPct val="100000"/>
-              </a:lnSpc>
-              <a:spcBef>
-                <a:spcPts val="0"/>
-              </a:spcBef>
-              <a:spcAft>
-                <a:spcPts val="0"/>
-              </a:spcAft>
-              <a:buClrTx/>
-              <a:buSzTx/>
-              <a:buFontTx/>
-              <a:buChar char="-"/>
-              <a:tabLst/>
-              <a:defRPr/>
-            </a:pPr>
-            <a:r>
-              <a:rPr lang="en-US" baseline="0" dirty="0"/>
-              <a:t>Explanation: upon start with a default configuration </a:t>
-            </a:r>
-            <a:r>
-              <a:rPr lang="en-US" baseline="0" dirty="0" err="1"/>
-              <a:t>nginx</a:t>
-            </a:r>
-            <a:r>
-              <a:rPr lang="en-US" baseline="0" dirty="0"/>
-              <a:t> looks at a /</a:t>
-            </a:r>
-            <a:r>
-              <a:rPr lang="en-US" baseline="0" dirty="0" err="1"/>
-              <a:t>usr</a:t>
-            </a:r>
-            <a:r>
-              <a:rPr lang="en-US" baseline="0" dirty="0"/>
-              <a:t>/share/</a:t>
-            </a:r>
-            <a:r>
-              <a:rPr lang="en-US" baseline="0" dirty="0" err="1"/>
-              <a:t>nginx</a:t>
-            </a:r>
-            <a:r>
-              <a:rPr lang="en-US" baseline="0" dirty="0"/>
-              <a:t>/html for an index.html file. If this file is not found, </a:t>
-            </a:r>
-            <a:r>
-              <a:rPr lang="en-US" baseline="0" dirty="0" err="1"/>
-              <a:t>nginx</a:t>
-            </a:r>
-            <a:r>
-              <a:rPr lang="en-US" baseline="0" dirty="0"/>
-              <a:t> attempts a “list directory” action, which is also </a:t>
-            </a:r>
-            <a:r>
-              <a:rPr lang="en-US" b="1" baseline="0" dirty="0"/>
-              <a:t>forbidden </a:t>
-            </a:r>
-            <a:r>
-              <a:rPr lang="en-US" b="0" baseline="0" dirty="0"/>
-              <a:t>in the default configuration.</a:t>
-            </a:r>
-            <a:endParaRPr lang="en-US" b="1" baseline="0" dirty="0"/>
-          </a:p>
-          <a:p>
-            <a:pPr marL="0" marR="0" lvl="0" indent="0" algn="l" defTabSz="1088776" rtl="0" eaLnBrk="1" fontAlgn="auto" latinLnBrk="0" hangingPunct="1">
-              <a:lnSpc>
-                <a:spcPct val="100000"/>
-              </a:lnSpc>
-              <a:spcBef>
-                <a:spcPts val="0"/>
-              </a:spcBef>
-              <a:spcAft>
-                <a:spcPts val="0"/>
-              </a:spcAft>
-              <a:buClrTx/>
-              <a:buSzTx/>
+            <a:endParaRPr lang="en-US" dirty="0"/>
+          </a:p>
+          <a:p>
+            <a:pPr marL="0" indent="0">
               <a:buFontTx/>
               <a:buNone/>
-              <a:tabLst/>
-              <a:defRPr/>
             </a:pPr>
-            <a:endParaRPr lang="en-US" baseline="0" dirty="0"/>
-          </a:p>
-          <a:p>
-            <a:pPr marL="0" marR="0" lvl="0" indent="0" algn="l" defTabSz="1088776" rtl="0" eaLnBrk="1" fontAlgn="auto" latinLnBrk="0" hangingPunct="1">
-              <a:lnSpc>
-                <a:spcPct val="100000"/>
-              </a:lnSpc>
-              <a:spcBef>
-                <a:spcPts val="0"/>
-              </a:spcBef>
-              <a:spcAft>
-                <a:spcPts val="0"/>
-              </a:spcAft>
-              <a:buClrTx/>
-              <a:buSzTx/>
-              <a:buFontTx/>
-              <a:buNone/>
-              <a:tabLst/>
-              <a:defRPr/>
-            </a:pPr>
-            <a:r>
-              <a:rPr lang="en-US" baseline="0" dirty="0"/>
-              <a:t>These 2 strategies can be used for application debugging. Usually issues are not connected to the cluster itself.</a:t>
+            <a:r>
+              <a:rPr lang="en-US" dirty="0"/>
+              <a:t>https://kubernetes.io/docs/tasks/debug-application-cluster/debug-running-pod/</a:t>
             </a:r>
           </a:p>
         </p:txBody>
@@ -2207,7 +2075,7 @@
     </p:spTree>
     <p:extLst>
       <p:ext uri="{BB962C8B-B14F-4D97-AF65-F5344CB8AC3E}">
-        <p14:creationId xmlns:p14="http://schemas.microsoft.com/office/powerpoint/2010/main" val="3277023380"/>
+        <p14:creationId xmlns:p14="http://schemas.microsoft.com/office/powerpoint/2010/main" val="1242961620"/>
       </p:ext>
     </p:extLst>
   </p:cSld>
@@ -2261,33 +2129,432 @@
           <a:bodyPr/>
           <a:lstStyle/>
           <a:p>
-            <a:r>
-              <a:rPr lang="en-US" dirty="0"/>
-              <a:t>In case something does not work as expected:</a:t>
-            </a:r>
-          </a:p>
-          <a:p>
-            <a:pPr marL="342900" indent="-342900">
-              <a:buAutoNum type="arabicParenR"/>
+            <a:pPr marL="285750" marR="0" lvl="0" indent="-285750" algn="l" defTabSz="1088776" rtl="0" eaLnBrk="1" fontAlgn="auto" latinLnBrk="0" hangingPunct="1">
+              <a:lnSpc>
+                <a:spcPct val="100000"/>
+              </a:lnSpc>
+              <a:spcBef>
+                <a:spcPts val="0"/>
+              </a:spcBef>
+              <a:spcAft>
+                <a:spcPts val="0"/>
+              </a:spcAft>
+              <a:buClrTx/>
+              <a:buSzTx/>
+              <a:buFontTx/>
+              <a:buChar char="-"/>
+              <a:tabLst/>
+              <a:defRPr/>
             </a:pPr>
             <a:r>
-              <a:rPr lang="en-US" dirty="0"/>
-              <a:t>In case the pod was not started, use “</a:t>
-            </a:r>
-            <a:r>
-              <a:rPr lang="en-US" dirty="0" err="1"/>
+              <a:rPr lang="en-US" baseline="0" dirty="0"/>
+              <a:t>Use the </a:t>
+            </a:r>
+            <a:r>
+              <a:rPr lang="en-US" baseline="0" dirty="0" err="1"/>
+              <a:t>crashloop</a:t>
+            </a:r>
+            <a:r>
+              <a:rPr lang="en-US" baseline="0" dirty="0"/>
+              <a:t> and </a:t>
+            </a:r>
+            <a:r>
+              <a:rPr lang="en-US" baseline="0" dirty="0" err="1"/>
+              <a:t>app_failure</a:t>
+            </a:r>
+            <a:r>
+              <a:rPr lang="en-US" baseline="0" dirty="0"/>
+              <a:t> demos </a:t>
+            </a:r>
+          </a:p>
+          <a:p>
+            <a:pPr marL="285750" marR="0" lvl="0" indent="-285750" algn="l" defTabSz="1088776" rtl="0" eaLnBrk="1" fontAlgn="auto" latinLnBrk="0" hangingPunct="1">
+              <a:lnSpc>
+                <a:spcPct val="100000"/>
+              </a:lnSpc>
+              <a:spcBef>
+                <a:spcPts val="0"/>
+              </a:spcBef>
+              <a:spcAft>
+                <a:spcPts val="0"/>
+              </a:spcAft>
+              <a:buClrTx/>
+              <a:buSzTx/>
+              <a:buFontTx/>
+              <a:buChar char="-"/>
+              <a:tabLst/>
+              <a:defRPr/>
+            </a:pPr>
+            <a:r>
+              <a:rPr lang="en-US" baseline="0" dirty="0" err="1"/>
+              <a:t>Crashloop</a:t>
+            </a:r>
+            <a:r>
+              <a:rPr lang="en-US" baseline="0" dirty="0"/>
+              <a:t>:</a:t>
+            </a:r>
+          </a:p>
+          <a:p>
+            <a:pPr marL="465750" marR="0" lvl="1" indent="-285750" algn="l" defTabSz="1088776" rtl="0" eaLnBrk="1" fontAlgn="auto" latinLnBrk="0" hangingPunct="1">
+              <a:lnSpc>
+                <a:spcPct val="100000"/>
+              </a:lnSpc>
+              <a:spcBef>
+                <a:spcPts val="0"/>
+              </a:spcBef>
+              <a:spcAft>
+                <a:spcPts val="0"/>
+              </a:spcAft>
+              <a:buClrTx/>
+              <a:buSzTx/>
+              <a:buFontTx/>
+              <a:buChar char="-"/>
+              <a:tabLst/>
+              <a:defRPr/>
+            </a:pPr>
+            <a:r>
+              <a:rPr lang="en-US" baseline="0" dirty="0"/>
+              <a:t>Show the </a:t>
+            </a:r>
+            <a:r>
+              <a:rPr lang="en-US" baseline="0" dirty="0" err="1"/>
+              <a:t>yaml</a:t>
+            </a:r>
+            <a:r>
+              <a:rPr lang="en-US" baseline="0" dirty="0"/>
+              <a:t> file</a:t>
+            </a:r>
+          </a:p>
+          <a:p>
+            <a:pPr marL="465750" marR="0" lvl="1" indent="-285750" algn="l" defTabSz="1088776" rtl="0" eaLnBrk="1" fontAlgn="auto" latinLnBrk="0" hangingPunct="1">
+              <a:lnSpc>
+                <a:spcPct val="100000"/>
+              </a:lnSpc>
+              <a:spcBef>
+                <a:spcPts val="0"/>
+              </a:spcBef>
+              <a:spcAft>
+                <a:spcPts val="0"/>
+              </a:spcAft>
+              <a:buClrTx/>
+              <a:buSzTx/>
+              <a:buFontTx/>
+              <a:buChar char="-"/>
+              <a:tabLst/>
+              <a:defRPr/>
+            </a:pPr>
+            <a:r>
+              <a:rPr lang="en-US" baseline="0" dirty="0"/>
+              <a:t>Run the pod and show the restart counter &amp; error message with </a:t>
+            </a:r>
+            <a:r>
+              <a:rPr lang="en-US" baseline="0" dirty="0" err="1"/>
               <a:t>kubectl</a:t>
             </a:r>
             <a:r>
-              <a:rPr lang="en-US" dirty="0"/>
-              <a:t> describe pod &lt;name&gt;” to look at events. They usually contain a hint about what went wrong</a:t>
-            </a:r>
-          </a:p>
-          <a:p>
-            <a:pPr marL="342900" indent="-342900">
-              <a:buAutoNum type="arabicParenR"/>
+              <a:rPr lang="en-US" baseline="0" dirty="0"/>
+              <a:t> get pods</a:t>
+            </a:r>
+          </a:p>
+          <a:p>
+            <a:pPr marL="465750" marR="0" lvl="1" indent="-285750" algn="l" defTabSz="1088776" rtl="0" eaLnBrk="1" fontAlgn="auto" latinLnBrk="0" hangingPunct="1">
+              <a:lnSpc>
+                <a:spcPct val="100000"/>
+              </a:lnSpc>
+              <a:spcBef>
+                <a:spcPts val="0"/>
+              </a:spcBef>
+              <a:spcAft>
+                <a:spcPts val="0"/>
+              </a:spcAft>
+              <a:buClrTx/>
+              <a:buSzTx/>
+              <a:buFontTx/>
+              <a:buChar char="-"/>
+              <a:tabLst/>
+              <a:defRPr/>
             </a:pPr>
-            <a:endParaRPr lang="en-US" dirty="0"/>
+            <a:r>
+              <a:rPr lang="en-US" baseline="0" dirty="0"/>
+              <a:t>Show the logs of the pod </a:t>
+            </a:r>
+            <a:r>
+              <a:rPr lang="en-US" baseline="0" dirty="0">
+                <a:sym typeface="Wingdings" panose="05000000000000000000" pitchFamily="2" charset="2"/>
+              </a:rPr>
+              <a:t> expected output: /bin/</a:t>
+            </a:r>
+            <a:r>
+              <a:rPr lang="en-US" baseline="0" dirty="0" err="1">
+                <a:sym typeface="Wingdings" panose="05000000000000000000" pitchFamily="2" charset="2"/>
+              </a:rPr>
+              <a:t>sh</a:t>
+            </a:r>
+            <a:r>
+              <a:rPr lang="en-US" baseline="0" dirty="0">
+                <a:sym typeface="Wingdings" panose="05000000000000000000" pitchFamily="2" charset="2"/>
+              </a:rPr>
+              <a:t>: no-such-</a:t>
+            </a:r>
+            <a:r>
+              <a:rPr lang="en-US" baseline="0" dirty="0" err="1">
+                <a:sym typeface="Wingdings" panose="05000000000000000000" pitchFamily="2" charset="2"/>
+              </a:rPr>
+              <a:t>cmd</a:t>
+            </a:r>
+            <a:r>
+              <a:rPr lang="en-US" baseline="0" dirty="0">
+                <a:sym typeface="Wingdings" panose="05000000000000000000" pitchFamily="2" charset="2"/>
+              </a:rPr>
+              <a:t>: not found</a:t>
+            </a:r>
+            <a:endParaRPr lang="en-US" baseline="0" dirty="0"/>
+          </a:p>
+          <a:p>
+            <a:pPr marL="285750" marR="0" lvl="0" indent="-285750" algn="l" defTabSz="1088776" rtl="0" eaLnBrk="1" fontAlgn="auto" latinLnBrk="0" hangingPunct="1">
+              <a:lnSpc>
+                <a:spcPct val="100000"/>
+              </a:lnSpc>
+              <a:spcBef>
+                <a:spcPts val="0"/>
+              </a:spcBef>
+              <a:spcAft>
+                <a:spcPts val="0"/>
+              </a:spcAft>
+              <a:buClrTx/>
+              <a:buSzTx/>
+              <a:buFontTx/>
+              <a:buChar char="-"/>
+              <a:tabLst/>
+              <a:defRPr/>
+            </a:pPr>
+            <a:r>
+              <a:rPr lang="en-US" baseline="0" dirty="0"/>
+              <a:t>App failure:</a:t>
+            </a:r>
+          </a:p>
+          <a:p>
+            <a:pPr marL="465750" marR="0" lvl="1" indent="-285750" algn="l" defTabSz="1088776" rtl="0" eaLnBrk="1" fontAlgn="auto" latinLnBrk="0" hangingPunct="1">
+              <a:lnSpc>
+                <a:spcPct val="100000"/>
+              </a:lnSpc>
+              <a:spcBef>
+                <a:spcPts val="0"/>
+              </a:spcBef>
+              <a:spcAft>
+                <a:spcPts val="0"/>
+              </a:spcAft>
+              <a:buClrTx/>
+              <a:buSzTx/>
+              <a:buFontTx/>
+              <a:buChar char="-"/>
+              <a:tabLst/>
+              <a:defRPr/>
+            </a:pPr>
+            <a:r>
+              <a:rPr lang="en-US" baseline="0" dirty="0"/>
+              <a:t>Show the </a:t>
+            </a:r>
+            <a:r>
+              <a:rPr lang="en-US" baseline="0" dirty="0" err="1"/>
+              <a:t>yaml</a:t>
+            </a:r>
+            <a:r>
+              <a:rPr lang="en-US" baseline="0" dirty="0"/>
+              <a:t> file</a:t>
+            </a:r>
+          </a:p>
+          <a:p>
+            <a:pPr marL="465750" marR="0" lvl="1" indent="-285750" algn="l" defTabSz="1088776" rtl="0" eaLnBrk="1" fontAlgn="auto" latinLnBrk="0" hangingPunct="1">
+              <a:lnSpc>
+                <a:spcPct val="100000"/>
+              </a:lnSpc>
+              <a:spcBef>
+                <a:spcPts val="0"/>
+              </a:spcBef>
+              <a:spcAft>
+                <a:spcPts val="0"/>
+              </a:spcAft>
+              <a:buClrTx/>
+              <a:buSzTx/>
+              <a:buFontTx/>
+              <a:buChar char="-"/>
+              <a:tabLst/>
+              <a:defRPr/>
+            </a:pPr>
+            <a:r>
+              <a:rPr lang="en-US" baseline="0" dirty="0"/>
+              <a:t>Start the pod and show it is running</a:t>
+            </a:r>
+          </a:p>
+          <a:p>
+            <a:pPr marL="465750" marR="0" lvl="1" indent="-285750" algn="l" defTabSz="1088776" rtl="0" eaLnBrk="1" fontAlgn="auto" latinLnBrk="0" hangingPunct="1">
+              <a:lnSpc>
+                <a:spcPct val="100000"/>
+              </a:lnSpc>
+              <a:spcBef>
+                <a:spcPts val="0"/>
+              </a:spcBef>
+              <a:spcAft>
+                <a:spcPts val="0"/>
+              </a:spcAft>
+              <a:buClrTx/>
+              <a:buSzTx/>
+              <a:buFontTx/>
+              <a:buChar char="-"/>
+              <a:tabLst/>
+              <a:defRPr/>
+            </a:pPr>
+            <a:r>
+              <a:rPr lang="en-US" baseline="0" dirty="0"/>
+              <a:t>Use port forward to get to the index.html page (</a:t>
+            </a:r>
+            <a:r>
+              <a:rPr lang="en-US" baseline="0" dirty="0" err="1"/>
+              <a:t>kubectl</a:t>
+            </a:r>
+            <a:r>
+              <a:rPr lang="en-US" baseline="0" dirty="0"/>
+              <a:t> port-forward app-failure 8080:80)</a:t>
+            </a:r>
+          </a:p>
+          <a:p>
+            <a:pPr marL="465750" marR="0" lvl="1" indent="-285750" algn="l" defTabSz="1088776" rtl="0" eaLnBrk="1" fontAlgn="auto" latinLnBrk="0" hangingPunct="1">
+              <a:lnSpc>
+                <a:spcPct val="100000"/>
+              </a:lnSpc>
+              <a:spcBef>
+                <a:spcPts val="0"/>
+              </a:spcBef>
+              <a:spcAft>
+                <a:spcPts val="0"/>
+              </a:spcAft>
+              <a:buClrTx/>
+              <a:buSzTx/>
+              <a:buFontTx/>
+              <a:buChar char="-"/>
+              <a:tabLst/>
+              <a:defRPr/>
+            </a:pPr>
+            <a:r>
+              <a:rPr lang="en-US" baseline="0" dirty="0"/>
+              <a:t>Show the error message with </a:t>
+            </a:r>
+            <a:r>
+              <a:rPr lang="en-US" baseline="0" dirty="0" err="1"/>
+              <a:t>kubectl</a:t>
+            </a:r>
+            <a:r>
+              <a:rPr lang="en-US" baseline="0" dirty="0"/>
+              <a:t> logs … &amp; exec into the pod. Show the directory without the index.html file</a:t>
+            </a:r>
+          </a:p>
+          <a:p>
+            <a:pPr marL="465750" marR="0" lvl="1" indent="-285750" algn="l" defTabSz="1088776" rtl="0" eaLnBrk="1" fontAlgn="auto" latinLnBrk="0" hangingPunct="1">
+              <a:lnSpc>
+                <a:spcPct val="100000"/>
+              </a:lnSpc>
+              <a:spcBef>
+                <a:spcPts val="0"/>
+              </a:spcBef>
+              <a:spcAft>
+                <a:spcPts val="0"/>
+              </a:spcAft>
+              <a:buClrTx/>
+              <a:buSzTx/>
+              <a:buFontTx/>
+              <a:buChar char="-"/>
+              <a:tabLst/>
+              <a:defRPr/>
+            </a:pPr>
+            <a:r>
+              <a:rPr lang="en-US" baseline="0" dirty="0"/>
+              <a:t>Explanation: upon start with a default configuration </a:t>
+            </a:r>
+            <a:r>
+              <a:rPr lang="en-US" baseline="0" dirty="0" err="1"/>
+              <a:t>nginx</a:t>
+            </a:r>
+            <a:r>
+              <a:rPr lang="en-US" baseline="0" dirty="0"/>
+              <a:t> looks at a /</a:t>
+            </a:r>
+            <a:r>
+              <a:rPr lang="en-US" baseline="0" dirty="0" err="1"/>
+              <a:t>usr</a:t>
+            </a:r>
+            <a:r>
+              <a:rPr lang="en-US" baseline="0" dirty="0"/>
+              <a:t>/share/</a:t>
+            </a:r>
+            <a:r>
+              <a:rPr lang="en-US" baseline="0" dirty="0" err="1"/>
+              <a:t>nginx</a:t>
+            </a:r>
+            <a:r>
+              <a:rPr lang="en-US" baseline="0" dirty="0"/>
+              <a:t>/html for an index.html file. If this file is not found, </a:t>
+            </a:r>
+            <a:r>
+              <a:rPr lang="en-US" baseline="0" dirty="0" err="1"/>
+              <a:t>nginx</a:t>
+            </a:r>
+            <a:r>
+              <a:rPr lang="en-US" baseline="0" dirty="0"/>
+              <a:t> attempts a “list directory” action, which is also </a:t>
+            </a:r>
+            <a:r>
+              <a:rPr lang="en-US" b="1" baseline="0" dirty="0"/>
+              <a:t>forbidden </a:t>
+            </a:r>
+            <a:r>
+              <a:rPr lang="en-US" b="0" baseline="0" dirty="0"/>
+              <a:t>in the default configuration.</a:t>
+            </a:r>
+            <a:endParaRPr lang="en-US" b="1" baseline="0" dirty="0"/>
+          </a:p>
+          <a:p>
+            <a:pPr marL="0" marR="0" lvl="0" indent="0" algn="l" defTabSz="1088776" rtl="0" eaLnBrk="1" fontAlgn="auto" latinLnBrk="0" hangingPunct="1">
+              <a:lnSpc>
+                <a:spcPct val="100000"/>
+              </a:lnSpc>
+              <a:spcBef>
+                <a:spcPts val="0"/>
+              </a:spcBef>
+              <a:spcAft>
+                <a:spcPts val="0"/>
+              </a:spcAft>
+              <a:buClrTx/>
+              <a:buSzTx/>
+              <a:buFontTx/>
+              <a:buNone/>
+              <a:tabLst/>
+              <a:defRPr/>
+            </a:pPr>
+            <a:endParaRPr lang="en-US" baseline="0" dirty="0"/>
+          </a:p>
+          <a:p>
+            <a:pPr marL="0" marR="0" lvl="0" indent="0" algn="l" defTabSz="1088776" rtl="0" eaLnBrk="1" fontAlgn="auto" latinLnBrk="0" hangingPunct="1">
+              <a:lnSpc>
+                <a:spcPct val="100000"/>
+              </a:lnSpc>
+              <a:spcBef>
+                <a:spcPts val="0"/>
+              </a:spcBef>
+              <a:spcAft>
+                <a:spcPts val="0"/>
+              </a:spcAft>
+              <a:buClrTx/>
+              <a:buSzTx/>
+              <a:buFontTx/>
+              <a:buNone/>
+              <a:tabLst/>
+              <a:defRPr/>
+            </a:pPr>
+            <a:r>
+              <a:rPr lang="en-US" baseline="0" dirty="0"/>
+              <a:t>These 2 strategies can be used for application debugging. Usually issues are not connected to the cluster itself.</a:t>
+            </a:r>
           </a:p>
         </p:txBody>
       </p:sp>
@@ -2318,7 +2585,7 @@
     </p:spTree>
     <p:extLst>
       <p:ext uri="{BB962C8B-B14F-4D97-AF65-F5344CB8AC3E}">
-        <p14:creationId xmlns:p14="http://schemas.microsoft.com/office/powerpoint/2010/main" val="2666865443"/>
+        <p14:creationId xmlns:p14="http://schemas.microsoft.com/office/powerpoint/2010/main" val="3277023380"/>
       </p:ext>
     </p:extLst>
   </p:cSld>
@@ -2374,33 +2641,8 @@
           <a:p>
             <a:r>
               <a:rPr lang="en-US" dirty="0"/>
-              <a:t>There are various reasons why a service may not be working properly. </a:t>
-            </a:r>
-            <a:r>
-              <a:rPr lang="en-US" dirty="0" err="1"/>
-              <a:t>Kube-dns</a:t>
-            </a:r>
-            <a:r>
-              <a:rPr lang="en-US" dirty="0"/>
-              <a:t> &amp; </a:t>
-            </a:r>
-            <a:r>
-              <a:rPr lang="en-US" dirty="0" err="1"/>
-              <a:t>kube</a:t>
-            </a:r>
-            <a:r>
-              <a:rPr lang="en-US" dirty="0"/>
-              <a:t>-proxy might have issues but most likely the issues during a training are user-specific.</a:t>
-            </a:r>
-          </a:p>
-          <a:p>
-            <a:r>
-              <a:rPr lang="en-US" dirty="0"/>
-              <a:t>So here are a few ideas how to debug a service based on the “describe command”</a:t>
-            </a:r>
-          </a:p>
-          <a:p>
-            <a:endParaRPr lang="en-US" dirty="0"/>
+              <a:t>In case something does not work as expected:</a:t>
+            </a:r>
           </a:p>
           <a:p>
             <a:pPr marL="342900" indent="-342900">
@@ -2408,24 +2650,7 @@
             </a:pPr>
             <a:r>
               <a:rPr lang="en-US" dirty="0"/>
-              <a:t>Are you using the correct set of labels (</a:t>
-            </a:r>
-            <a:r>
-              <a:rPr lang="en-US" dirty="0" err="1"/>
-              <a:t>key:value</a:t>
-            </a:r>
-            <a:r>
-              <a:rPr lang="en-US" dirty="0"/>
-              <a:t> pairs) to select pods that should be managed by the service?</a:t>
-            </a:r>
-          </a:p>
-          <a:p>
-            <a:pPr marL="180000" lvl="1" indent="0">
-              <a:buNone/>
-            </a:pPr>
-            <a:r>
-              <a:rPr lang="en-US" dirty="0"/>
-              <a:t>    Test with “</a:t>
+              <a:t>In case the pod was not started, use “</a:t>
             </a:r>
             <a:r>
               <a:rPr lang="en-US" dirty="0" err="1"/>
@@ -2433,26 +2658,14 @@
             </a:r>
             <a:r>
               <a:rPr lang="en-US" dirty="0"/>
-              <a:t> get pods –l &lt;key&gt;=&lt;value&gt;” as described in the selector of the service.</a:t>
+              <a:t> describe pod &lt;name&gt;” to look at events. They usually contain a hint about what went wrong</a:t>
             </a:r>
           </a:p>
           <a:p>
             <a:pPr marL="342900" indent="-342900">
               <a:buAutoNum type="arabicParenR"/>
             </a:pPr>
-            <a:r>
-              <a:rPr lang="en-US" dirty="0"/>
-              <a:t>Are you targeting the correct port? The target port is the port specified in the pod spec.</a:t>
-            </a:r>
-          </a:p>
-          <a:p>
-            <a:pPr marL="342900" indent="-342900">
-              <a:buAutoNum type="arabicParenR"/>
-            </a:pPr>
-            <a:r>
-              <a:rPr lang="en-US" dirty="0"/>
-              <a:t>Are there any pods available? The “Endpoints” part of the description lists all the IP addresses of the pods identified by the label. Run the query with from step 1 with “-o wide” and check for the IP addresses. If there are no endpoints listed, either the label/selector part is wrong or there are simply no pods (e.g. because someone deleted the deployment)</a:t>
-            </a:r>
+            <a:endParaRPr lang="en-US" dirty="0"/>
           </a:p>
         </p:txBody>
       </p:sp>
@@ -2483,7 +2696,7 @@
     </p:spTree>
     <p:extLst>
       <p:ext uri="{BB962C8B-B14F-4D97-AF65-F5344CB8AC3E}">
-        <p14:creationId xmlns:p14="http://schemas.microsoft.com/office/powerpoint/2010/main" val="1210700300"/>
+        <p14:creationId xmlns:p14="http://schemas.microsoft.com/office/powerpoint/2010/main" val="2666865443"/>
       </p:ext>
     </p:extLst>
   </p:cSld>
@@ -15942,6 +16155,542 @@
       </p:grpSpPr>
       <p:sp>
         <p:nvSpPr>
+          <p:cNvPr id="2" name="Title 1">
+            <a:extLst>
+              <a:ext uri="{FF2B5EF4-FFF2-40B4-BE49-F238E27FC236}">
+                <a16:creationId xmlns:a16="http://schemas.microsoft.com/office/drawing/2014/main" id="{B5CAB707-1225-4D64-A95E-F1193D92F3BE}"/>
+              </a:ext>
+            </a:extLst>
+          </p:cNvPr>
+          <p:cNvSpPr>
+            <a:spLocks noGrp="1"/>
+          </p:cNvSpPr>
+          <p:nvPr>
+            <p:ph type="title"/>
+          </p:nvPr>
+        </p:nvSpPr>
+        <p:spPr/>
+        <p:txBody>
+          <a:bodyPr/>
+          <a:lstStyle/>
+          <a:p>
+            <a:r>
+              <a:rPr lang="en-US" dirty="0"/>
+              <a:t>Issues with services</a:t>
+            </a:r>
+          </a:p>
+        </p:txBody>
+      </p:sp>
+      <p:sp>
+        <p:nvSpPr>
+          <p:cNvPr id="3" name="Rectangle 2">
+            <a:extLst>
+              <a:ext uri="{FF2B5EF4-FFF2-40B4-BE49-F238E27FC236}">
+                <a16:creationId xmlns:a16="http://schemas.microsoft.com/office/drawing/2014/main" id="{B6791FF6-F4CE-4E9F-BD65-77201830485B}"/>
+              </a:ext>
+            </a:extLst>
+          </p:cNvPr>
+          <p:cNvSpPr/>
+          <p:nvPr/>
+        </p:nvSpPr>
+        <p:spPr>
+          <a:xfrm>
+            <a:off x="504001" y="6021077"/>
+            <a:ext cx="9606354" cy="415498"/>
+          </a:xfrm>
+          <a:prstGeom prst="rect">
+            <a:avLst/>
+          </a:prstGeom>
+        </p:spPr>
+        <p:txBody>
+          <a:bodyPr wrap="square">
+            <a:spAutoFit/>
+          </a:bodyPr>
+          <a:lstStyle/>
+          <a:p>
+            <a:r>
+              <a:rPr lang="en-US" dirty="0">
+                <a:hlinkClick r:id="rId3"/>
+              </a:rPr>
+              <a:t>https://kubernetes.io/docs/tasks/debug-application-cluster/debug-service/</a:t>
+            </a:r>
+            <a:r>
+              <a:rPr lang="en-US" dirty="0"/>
+              <a:t> </a:t>
+            </a:r>
+          </a:p>
+        </p:txBody>
+      </p:sp>
+      <p:sp>
+        <p:nvSpPr>
+          <p:cNvPr id="4" name="Rectangle 3">
+            <a:extLst>
+              <a:ext uri="{FF2B5EF4-FFF2-40B4-BE49-F238E27FC236}">
+                <a16:creationId xmlns:a16="http://schemas.microsoft.com/office/drawing/2014/main" id="{8EA39D1E-A943-46DB-91C6-E6352F757421}"/>
+              </a:ext>
+            </a:extLst>
+          </p:cNvPr>
+          <p:cNvSpPr/>
+          <p:nvPr/>
+        </p:nvSpPr>
+        <p:spPr>
+          <a:xfrm>
+            <a:off x="504000" y="1345168"/>
+            <a:ext cx="9751827" cy="4524315"/>
+          </a:xfrm>
+          <a:prstGeom prst="rect">
+            <a:avLst/>
+          </a:prstGeom>
+        </p:spPr>
+        <p:txBody>
+          <a:bodyPr wrap="square">
+            <a:spAutoFit/>
+          </a:bodyPr>
+          <a:lstStyle/>
+          <a:p>
+            <a:r>
+              <a:rPr lang="en-US" sz="2400" b="1" kern="0" dirty="0" err="1">
+                <a:solidFill>
+                  <a:schemeClr val="accent1">
+                    <a:lumMod val="75000"/>
+                  </a:schemeClr>
+                </a:solidFill>
+                <a:latin typeface="Courier New" panose="02070309020205020404" pitchFamily="49" charset="0"/>
+                <a:ea typeface="Arial Unicode MS" pitchFamily="34" charset="-128"/>
+                <a:cs typeface="Courier New" panose="02070309020205020404" pitchFamily="49" charset="0"/>
+              </a:rPr>
+              <a:t>kubectl</a:t>
+            </a:r>
+            <a:r>
+              <a:rPr lang="en-US" sz="2400" b="1" kern="0" dirty="0">
+                <a:solidFill>
+                  <a:schemeClr val="accent1">
+                    <a:lumMod val="75000"/>
+                  </a:schemeClr>
+                </a:solidFill>
+                <a:latin typeface="Courier New" panose="02070309020205020404" pitchFamily="49" charset="0"/>
+                <a:ea typeface="Arial Unicode MS" pitchFamily="34" charset="-128"/>
+                <a:cs typeface="Courier New" panose="02070309020205020404" pitchFamily="49" charset="0"/>
+              </a:rPr>
+              <a:t> -n </a:t>
+            </a:r>
+            <a:r>
+              <a:rPr lang="en-US" sz="2400" b="1" kern="0" dirty="0" err="1">
+                <a:solidFill>
+                  <a:schemeClr val="accent1">
+                    <a:lumMod val="75000"/>
+                  </a:schemeClr>
+                </a:solidFill>
+                <a:latin typeface="Courier New" panose="02070309020205020404" pitchFamily="49" charset="0"/>
+                <a:ea typeface="Arial Unicode MS" pitchFamily="34" charset="-128"/>
+                <a:cs typeface="Courier New" panose="02070309020205020404" pitchFamily="49" charset="0"/>
+              </a:rPr>
+              <a:t>kube</a:t>
+            </a:r>
+            <a:r>
+              <a:rPr lang="en-US" sz="2400" b="1" kern="0" dirty="0">
+                <a:solidFill>
+                  <a:schemeClr val="accent1">
+                    <a:lumMod val="75000"/>
+                  </a:schemeClr>
+                </a:solidFill>
+                <a:latin typeface="Courier New" panose="02070309020205020404" pitchFamily="49" charset="0"/>
+                <a:ea typeface="Arial Unicode MS" pitchFamily="34" charset="-128"/>
+                <a:cs typeface="Courier New" panose="02070309020205020404" pitchFamily="49" charset="0"/>
+              </a:rPr>
+              <a:t>-system describe svc node-exporter</a:t>
+            </a:r>
+          </a:p>
+          <a:p>
+            <a:endParaRPr lang="en-US" sz="2400" b="1" kern="0" dirty="0">
+              <a:latin typeface="Courier New" panose="02070309020205020404" pitchFamily="49" charset="0"/>
+              <a:ea typeface="Arial Unicode MS" pitchFamily="34" charset="-128"/>
+              <a:cs typeface="Courier New" panose="02070309020205020404" pitchFamily="49" charset="0"/>
+            </a:endParaRPr>
+          </a:p>
+          <a:p>
+            <a:r>
+              <a:rPr lang="en-US" sz="2400" b="1" kern="0" dirty="0">
+                <a:latin typeface="Courier New" panose="02070309020205020404" pitchFamily="49" charset="0"/>
+                <a:ea typeface="Arial Unicode MS" pitchFamily="34" charset="-128"/>
+                <a:cs typeface="Courier New" panose="02070309020205020404" pitchFamily="49" charset="0"/>
+              </a:rPr>
+              <a:t>…</a:t>
+            </a:r>
+          </a:p>
+          <a:p>
+            <a:r>
+              <a:rPr lang="en-US" sz="2400" b="1" kern="0" dirty="0">
+                <a:latin typeface="Courier New" panose="02070309020205020404" pitchFamily="49" charset="0"/>
+                <a:ea typeface="Arial Unicode MS" pitchFamily="34" charset="-128"/>
+                <a:cs typeface="Courier New" panose="02070309020205020404" pitchFamily="49" charset="0"/>
+              </a:rPr>
+              <a:t>Selector:          component=node-exporter</a:t>
+            </a:r>
+          </a:p>
+          <a:p>
+            <a:r>
+              <a:rPr lang="en-US" sz="2400" b="1" kern="0" dirty="0">
+                <a:latin typeface="Courier New" panose="02070309020205020404" pitchFamily="49" charset="0"/>
+                <a:ea typeface="Arial Unicode MS" pitchFamily="34" charset="-128"/>
+                <a:cs typeface="Courier New" panose="02070309020205020404" pitchFamily="49" charset="0"/>
+              </a:rPr>
+              <a:t>Type:              </a:t>
+            </a:r>
+            <a:r>
+              <a:rPr lang="en-US" sz="2400" b="1" kern="0" dirty="0" err="1">
+                <a:latin typeface="Courier New" panose="02070309020205020404" pitchFamily="49" charset="0"/>
+                <a:ea typeface="Arial Unicode MS" pitchFamily="34" charset="-128"/>
+                <a:cs typeface="Courier New" panose="02070309020205020404" pitchFamily="49" charset="0"/>
+              </a:rPr>
+              <a:t>ClusterIP</a:t>
+            </a:r>
+            <a:endParaRPr lang="en-US" sz="2400" b="1" kern="0" dirty="0">
+              <a:latin typeface="Courier New" panose="02070309020205020404" pitchFamily="49" charset="0"/>
+              <a:ea typeface="Arial Unicode MS" pitchFamily="34" charset="-128"/>
+              <a:cs typeface="Courier New" panose="02070309020205020404" pitchFamily="49" charset="0"/>
+            </a:endParaRPr>
+          </a:p>
+          <a:p>
+            <a:r>
+              <a:rPr lang="en-US" sz="2400" b="1" kern="0" dirty="0">
+                <a:latin typeface="Courier New" panose="02070309020205020404" pitchFamily="49" charset="0"/>
+                <a:ea typeface="Arial Unicode MS" pitchFamily="34" charset="-128"/>
+                <a:cs typeface="Courier New" panose="02070309020205020404" pitchFamily="49" charset="0"/>
+              </a:rPr>
+              <a:t>IP:                None</a:t>
+            </a:r>
+          </a:p>
+          <a:p>
+            <a:r>
+              <a:rPr lang="en-US" sz="2400" b="1" kern="0" dirty="0">
+                <a:latin typeface="Courier New" panose="02070309020205020404" pitchFamily="49" charset="0"/>
+                <a:ea typeface="Arial Unicode MS" pitchFamily="34" charset="-128"/>
+                <a:cs typeface="Courier New" panose="02070309020205020404" pitchFamily="49" charset="0"/>
+              </a:rPr>
+              <a:t>Port:              metrics  9100/TCP</a:t>
+            </a:r>
+          </a:p>
+          <a:p>
+            <a:r>
+              <a:rPr lang="en-US" sz="2400" b="1" kern="0" dirty="0" err="1">
+                <a:latin typeface="Courier New" panose="02070309020205020404" pitchFamily="49" charset="0"/>
+                <a:ea typeface="Arial Unicode MS" pitchFamily="34" charset="-128"/>
+                <a:cs typeface="Courier New" panose="02070309020205020404" pitchFamily="49" charset="0"/>
+              </a:rPr>
+              <a:t>TargetPort</a:t>
+            </a:r>
+            <a:r>
+              <a:rPr lang="en-US" sz="2400" b="1" kern="0" dirty="0">
+                <a:latin typeface="Courier New" panose="02070309020205020404" pitchFamily="49" charset="0"/>
+                <a:ea typeface="Arial Unicode MS" pitchFamily="34" charset="-128"/>
+                <a:cs typeface="Courier New" panose="02070309020205020404" pitchFamily="49" charset="0"/>
+              </a:rPr>
+              <a:t>:        9100/TCP</a:t>
+            </a:r>
+          </a:p>
+          <a:p>
+            <a:r>
+              <a:rPr lang="en-US" sz="2400" b="1" kern="0" dirty="0">
+                <a:latin typeface="Courier New" panose="02070309020205020404" pitchFamily="49" charset="0"/>
+                <a:ea typeface="Arial Unicode MS" pitchFamily="34" charset="-128"/>
+                <a:cs typeface="Courier New" panose="02070309020205020404" pitchFamily="49" charset="0"/>
+              </a:rPr>
+              <a:t>Endpoints:            10.250.0.2:9100,10.250.0.3:9100,10.250.0.4:9100</a:t>
+            </a:r>
+          </a:p>
+          <a:p>
+            <a:r>
+              <a:rPr lang="en-US" sz="2400" b="1" kern="0" dirty="0">
+                <a:latin typeface="Courier New" panose="02070309020205020404" pitchFamily="49" charset="0"/>
+                <a:ea typeface="Arial Unicode MS" pitchFamily="34" charset="-128"/>
+                <a:cs typeface="Courier New" panose="02070309020205020404" pitchFamily="49" charset="0"/>
+              </a:rPr>
+              <a:t>Session Affinity:  None</a:t>
+            </a:r>
+          </a:p>
+          <a:p>
+            <a:r>
+              <a:rPr lang="en-US" sz="2400" b="1" kern="0" dirty="0">
+                <a:latin typeface="Courier New" panose="02070309020205020404" pitchFamily="49" charset="0"/>
+                <a:ea typeface="Arial Unicode MS" pitchFamily="34" charset="-128"/>
+                <a:cs typeface="Courier New" panose="02070309020205020404" pitchFamily="49" charset="0"/>
+              </a:rPr>
+              <a:t>Events:            &lt;none&gt;</a:t>
+            </a:r>
+          </a:p>
+        </p:txBody>
+      </p:sp>
+      <p:sp>
+        <p:nvSpPr>
+          <p:cNvPr id="5" name="Speech Bubble: Rectangle 4">
+            <a:extLst>
+              <a:ext uri="{FF2B5EF4-FFF2-40B4-BE49-F238E27FC236}">
+                <a16:creationId xmlns:a16="http://schemas.microsoft.com/office/drawing/2014/main" id="{39365804-9B3C-4E0D-AC45-AF4553A32332}"/>
+              </a:ext>
+            </a:extLst>
+          </p:cNvPr>
+          <p:cNvSpPr/>
+          <p:nvPr/>
+        </p:nvSpPr>
+        <p:spPr bwMode="gray">
+          <a:xfrm>
+            <a:off x="9023050" y="1838837"/>
+            <a:ext cx="2667427" cy="677425"/>
+          </a:xfrm>
+          <a:prstGeom prst="wedgeRectCallout">
+            <a:avLst>
+              <a:gd name="adj1" fmla="val -73263"/>
+              <a:gd name="adj2" fmla="val 64322"/>
+            </a:avLst>
+          </a:prstGeom>
+          <a:ln>
+            <a:headEnd/>
+            <a:tailEnd/>
+          </a:ln>
+        </p:spPr>
+        <p:style>
+          <a:lnRef idx="2">
+            <a:schemeClr val="accent5"/>
+          </a:lnRef>
+          <a:fillRef idx="1">
+            <a:schemeClr val="lt1"/>
+          </a:fillRef>
+          <a:effectRef idx="0">
+            <a:schemeClr val="accent5"/>
+          </a:effectRef>
+          <a:fontRef idx="minor">
+            <a:schemeClr val="dk1"/>
+          </a:fontRef>
+        </p:style>
+        <p:txBody>
+          <a:bodyPr lIns="90000" tIns="72000" rIns="90000" bIns="72000" rtlCol="0" anchor="ctr"/>
+          <a:lstStyle/>
+          <a:p>
+            <a:pPr marR="0" algn="ctr" defTabSz="914400" eaLnBrk="1" fontAlgn="base" latinLnBrk="0" hangingPunct="1">
+              <a:lnSpc>
+                <a:spcPct val="100000"/>
+              </a:lnSpc>
+              <a:spcBef>
+                <a:spcPct val="50000"/>
+              </a:spcBef>
+              <a:spcAft>
+                <a:spcPct val="0"/>
+              </a:spcAft>
+              <a:buClr>
+                <a:srgbClr val="F0AB00"/>
+              </a:buClr>
+              <a:buSzPct val="80000"/>
+              <a:tabLst/>
+            </a:pPr>
+            <a:r>
+              <a:rPr lang="en-US" sz="1800" kern="0" dirty="0">
+                <a:ea typeface="Arial Unicode MS" pitchFamily="34" charset="-128"/>
+                <a:cs typeface="Arial Unicode MS" pitchFamily="34" charset="-128"/>
+              </a:rPr>
+              <a:t>Correct labels?</a:t>
+            </a:r>
+            <a:endParaRPr kumimoji="0" lang="en-US" sz="1800" b="0" i="0" u="none" strike="noStrike" kern="0" cap="none" spc="0" normalizeH="0" baseline="0" noProof="0" dirty="0">
+              <a:ln>
+                <a:noFill/>
+              </a:ln>
+              <a:effectLst/>
+              <a:uLnTx/>
+              <a:uFillTx/>
+              <a:ea typeface="Arial Unicode MS" pitchFamily="34" charset="-128"/>
+              <a:cs typeface="Arial Unicode MS" pitchFamily="34" charset="-128"/>
+            </a:endParaRPr>
+          </a:p>
+        </p:txBody>
+      </p:sp>
+      <p:sp>
+        <p:nvSpPr>
+          <p:cNvPr id="6" name="Speech Bubble: Rectangle 5">
+            <a:extLst>
+              <a:ext uri="{FF2B5EF4-FFF2-40B4-BE49-F238E27FC236}">
+                <a16:creationId xmlns:a16="http://schemas.microsoft.com/office/drawing/2014/main" id="{B6BA9F4F-D22A-42EF-9C65-EBE3C7731785}"/>
+              </a:ext>
+            </a:extLst>
+          </p:cNvPr>
+          <p:cNvSpPr/>
+          <p:nvPr/>
+        </p:nvSpPr>
+        <p:spPr bwMode="gray">
+          <a:xfrm>
+            <a:off x="9023049" y="3268612"/>
+            <a:ext cx="2667427" cy="677425"/>
+          </a:xfrm>
+          <a:prstGeom prst="wedgeRectCallout">
+            <a:avLst>
+              <a:gd name="adj1" fmla="val -73263"/>
+              <a:gd name="adj2" fmla="val 64322"/>
+            </a:avLst>
+          </a:prstGeom>
+          <a:ln>
+            <a:headEnd/>
+            <a:tailEnd/>
+          </a:ln>
+        </p:spPr>
+        <p:style>
+          <a:lnRef idx="2">
+            <a:schemeClr val="accent5"/>
+          </a:lnRef>
+          <a:fillRef idx="1">
+            <a:schemeClr val="lt1"/>
+          </a:fillRef>
+          <a:effectRef idx="0">
+            <a:schemeClr val="accent5"/>
+          </a:effectRef>
+          <a:fontRef idx="minor">
+            <a:schemeClr val="dk1"/>
+          </a:fontRef>
+        </p:style>
+        <p:txBody>
+          <a:bodyPr lIns="90000" tIns="72000" rIns="90000" bIns="72000" rtlCol="0" anchor="ctr"/>
+          <a:lstStyle/>
+          <a:p>
+            <a:pPr marR="0" algn="ctr" defTabSz="914400" eaLnBrk="1" fontAlgn="base" latinLnBrk="0" hangingPunct="1">
+              <a:lnSpc>
+                <a:spcPct val="100000"/>
+              </a:lnSpc>
+              <a:spcBef>
+                <a:spcPct val="50000"/>
+              </a:spcBef>
+              <a:spcAft>
+                <a:spcPct val="0"/>
+              </a:spcAft>
+              <a:buClr>
+                <a:srgbClr val="F0AB00"/>
+              </a:buClr>
+              <a:buSzPct val="80000"/>
+              <a:tabLst/>
+            </a:pPr>
+            <a:r>
+              <a:rPr kumimoji="0" lang="en-US" sz="1800" b="0" i="0" u="none" strike="noStrike" kern="0" cap="none" spc="0" normalizeH="0" baseline="0" noProof="0" dirty="0">
+                <a:ln>
+                  <a:noFill/>
+                </a:ln>
+                <a:effectLst/>
+                <a:uLnTx/>
+                <a:uFillTx/>
+                <a:ea typeface="Arial Unicode MS" pitchFamily="34" charset="-128"/>
+                <a:cs typeface="Arial Unicode MS" pitchFamily="34" charset="-128"/>
+              </a:rPr>
+              <a:t>Correct target port of pods? </a:t>
+            </a:r>
+          </a:p>
+        </p:txBody>
+      </p:sp>
+      <p:sp>
+        <p:nvSpPr>
+          <p:cNvPr id="7" name="Speech Bubble: Rectangle 6">
+            <a:extLst>
+              <a:ext uri="{FF2B5EF4-FFF2-40B4-BE49-F238E27FC236}">
+                <a16:creationId xmlns:a16="http://schemas.microsoft.com/office/drawing/2014/main" id="{A18D8DEB-83CF-4D76-BC6D-2B1E52C31FBC}"/>
+              </a:ext>
+            </a:extLst>
+          </p:cNvPr>
+          <p:cNvSpPr/>
+          <p:nvPr/>
+        </p:nvSpPr>
+        <p:spPr bwMode="gray">
+          <a:xfrm>
+            <a:off x="9023049" y="5229520"/>
+            <a:ext cx="2667427" cy="677425"/>
+          </a:xfrm>
+          <a:prstGeom prst="wedgeRectCallout">
+            <a:avLst>
+              <a:gd name="adj1" fmla="val -75990"/>
+              <a:gd name="adj2" fmla="val -55321"/>
+            </a:avLst>
+          </a:prstGeom>
+          <a:ln>
+            <a:headEnd/>
+            <a:tailEnd/>
+          </a:ln>
+        </p:spPr>
+        <p:style>
+          <a:lnRef idx="2">
+            <a:schemeClr val="accent5"/>
+          </a:lnRef>
+          <a:fillRef idx="1">
+            <a:schemeClr val="lt1"/>
+          </a:fillRef>
+          <a:effectRef idx="0">
+            <a:schemeClr val="accent5"/>
+          </a:effectRef>
+          <a:fontRef idx="minor">
+            <a:schemeClr val="dk1"/>
+          </a:fontRef>
+        </p:style>
+        <p:txBody>
+          <a:bodyPr lIns="90000" tIns="72000" rIns="90000" bIns="72000" rtlCol="0" anchor="ctr"/>
+          <a:lstStyle/>
+          <a:p>
+            <a:pPr marR="0" algn="ctr" defTabSz="914400" eaLnBrk="1" fontAlgn="base" latinLnBrk="0" hangingPunct="1">
+              <a:lnSpc>
+                <a:spcPct val="100000"/>
+              </a:lnSpc>
+              <a:spcBef>
+                <a:spcPct val="50000"/>
+              </a:spcBef>
+              <a:spcAft>
+                <a:spcPct val="0"/>
+              </a:spcAft>
+              <a:buClr>
+                <a:srgbClr val="F0AB00"/>
+              </a:buClr>
+              <a:buSzPct val="80000"/>
+              <a:tabLst/>
+            </a:pPr>
+            <a:r>
+              <a:rPr kumimoji="0" lang="en-US" sz="1800" b="0" i="0" u="none" strike="noStrike" kern="0" cap="none" spc="0" normalizeH="0" baseline="0" noProof="0" dirty="0">
+                <a:ln>
+                  <a:noFill/>
+                </a:ln>
+                <a:effectLst/>
+                <a:uLnTx/>
+                <a:uFillTx/>
+                <a:ea typeface="Arial Unicode MS" pitchFamily="34" charset="-128"/>
+                <a:cs typeface="Arial Unicode MS" pitchFamily="34" charset="-128"/>
+              </a:rPr>
+              <a:t>Are any pods available?</a:t>
+            </a:r>
+          </a:p>
+        </p:txBody>
+      </p:sp>
+    </p:spTree>
+    <p:extLst>
+      <p:ext uri="{BB962C8B-B14F-4D97-AF65-F5344CB8AC3E}">
+        <p14:creationId xmlns:p14="http://schemas.microsoft.com/office/powerpoint/2010/main" val="1979287927"/>
+      </p:ext>
+    </p:extLst>
+  </p:cSld>
+  <p:clrMapOvr>
+    <a:masterClrMapping/>
+  </p:clrMapOvr>
+</p:sld>
+</file>
+
+<file path=ppt/slides/slide11.xml><?xml version="1.0" encoding="utf-8"?>
+<p:sld xmlns:a="http://schemas.openxmlformats.org/drawingml/2006/main" xmlns:r="http://schemas.openxmlformats.org/officeDocument/2006/relationships" xmlns:p="http://schemas.openxmlformats.org/presentationml/2006/main">
+  <p:cSld>
+    <p:spTree>
+      <p:nvGrpSpPr>
+        <p:cNvPr id="1" name=""/>
+        <p:cNvGrpSpPr/>
+        <p:nvPr/>
+      </p:nvGrpSpPr>
+      <p:grpSpPr>
+        <a:xfrm>
+          <a:off x="0" y="0"/>
+          <a:ext cx="0" cy="0"/>
+          <a:chOff x="0" y="0"/>
+          <a:chExt cx="0" cy="0"/>
+        </a:xfrm>
+      </p:grpSpPr>
+      <p:sp>
+        <p:nvSpPr>
           <p:cNvPr id="3" name="Title 2"/>
           <p:cNvSpPr>
             <a:spLocks noGrp="1"/>
@@ -16005,7 +16754,7 @@
 </p:sld>
 </file>
 
-<file path=ppt/slides/slide11.xml><?xml version="1.0" encoding="utf-8"?>
+<file path=ppt/slides/slide12.xml><?xml version="1.0" encoding="utf-8"?>
 <p:sld xmlns:a="http://schemas.openxmlformats.org/drawingml/2006/main" xmlns:r="http://schemas.openxmlformats.org/officeDocument/2006/relationships" xmlns:p="http://schemas.openxmlformats.org/presentationml/2006/main" show="0">
   <p:cSld>
     <p:spTree>
@@ -16182,13 +16931,22 @@
               <a:t> </a:t>
             </a:r>
             <a:r>
+              <a:rPr lang="en-US" b="1" strike="sngStrike" cap="all" dirty="0">
+                <a:solidFill>
+                  <a:srgbClr val="F7931E"/>
+                </a:solidFill>
+                <a:latin typeface="bebas_neuebold"/>
+              </a:rPr>
+              <a:t>CRASHING POD</a:t>
+            </a:r>
+            <a:r>
               <a:rPr lang="en-US" b="1" cap="all" dirty="0">
                 <a:solidFill>
                   <a:srgbClr val="F7931E"/>
                 </a:solidFill>
                 <a:latin typeface="bebas_neuebold"/>
               </a:rPr>
-              <a:t>EXPLODING KITTEN</a:t>
+              <a:t> EXPLODING Kitten</a:t>
             </a:r>
             <a:r>
               <a:rPr lang="en-US" b="1" cap="all" dirty="0">
@@ -16880,8 +17638,8 @@
         </p:nvSpPr>
         <p:spPr>
           <a:xfrm>
-            <a:off x="1000498" y="541920"/>
-            <a:ext cx="10193482" cy="1061829"/>
+            <a:off x="601363" y="1006213"/>
+            <a:ext cx="10824518" cy="738664"/>
           </a:xfrm>
           <a:prstGeom prst="rect">
             <a:avLst/>
@@ -16896,21 +17654,30 @@
             <a:pPr algn="ctr"/>
             <a:r>
               <a:rPr lang="en-US" b="1" cap="all" dirty="0">
-                <a:solidFill>
-                  <a:srgbClr val="FAFAFA"/>
-                </a:solidFill>
                 <a:latin typeface="bebas_neuebold"/>
               </a:rPr>
-              <a:t>UNLESS!</a:t>
-            </a:r>
-          </a:p>
-          <a:p>
-            <a:pPr algn="ctr"/>
+              <a:t>YOU PLAY </a:t>
+            </a:r>
+            <a:r>
+              <a:rPr lang="en-US" b="1" strike="sngStrike" cap="all" dirty="0">
+                <a:latin typeface="bebas_neuebold"/>
+              </a:rPr>
+              <a:t>YOUR </a:t>
+            </a:r>
+            <a:r>
+              <a:rPr lang="en-US" b="1" strike="sngStrike" cap="all" dirty="0">
+                <a:solidFill>
+                  <a:srgbClr val="8CC63F"/>
+                </a:solidFill>
+                <a:latin typeface="bebas_neuebold"/>
+              </a:rPr>
+              <a:t>KNOWLEDGE</a:t>
+            </a:r>
             <a:r>
               <a:rPr lang="en-US" b="1" cap="all" dirty="0">
                 <a:latin typeface="bebas_neuebold"/>
               </a:rPr>
-              <a:t>YOU PLAY A</a:t>
+              <a:t> A</a:t>
             </a:r>
             <a:r>
               <a:rPr lang="en-US" b="1" cap="all" dirty="0">
@@ -16943,18 +17710,7 @@
               <a:rPr lang="en-US" b="1" cap="all" dirty="0">
                 <a:latin typeface="bebas_neuebold"/>
               </a:rPr>
-              <a:t>CARD, WHICH WILL STOP THE KITTEN FROM EXPLODING </a:t>
-            </a:r>
-            <a:br>
-              <a:rPr lang="en-US" b="1" cap="all" dirty="0">
-                <a:latin typeface="bebas_neuebold"/>
-              </a:rPr>
-            </a:br>
-            <a:r>
-              <a:rPr lang="en-US" b="1" cap="all" dirty="0">
-                <a:latin typeface="bebas_neuebold"/>
-              </a:rPr>
-              <a:t>USING THINGS LIKE LASER POINTERS, KITTEN YOGA, AND CATNIP SANDWICHES.</a:t>
+              <a:t>CARD, WHICH WILL STOP THE KITTEN FROM EXPLODING USING THINGS LIKE LASER POINTERS, KITTEN YOGA, AND CATNIP SANDWICHES.</a:t>
             </a:r>
             <a:endParaRPr lang="en-US" b="1" i="0" cap="all" dirty="0">
               <a:effectLst/>
@@ -17793,6 +18549,550 @@
       </p:grpSpPr>
       <p:sp>
         <p:nvSpPr>
+          <p:cNvPr id="2" name="Title 1">
+            <a:extLst>
+              <a:ext uri="{FF2B5EF4-FFF2-40B4-BE49-F238E27FC236}">
+                <a16:creationId xmlns:a16="http://schemas.microsoft.com/office/drawing/2014/main" id="{A1F96985-8F3C-4F8E-A840-866A7297AAB1}"/>
+              </a:ext>
+            </a:extLst>
+          </p:cNvPr>
+          <p:cNvSpPr>
+            <a:spLocks noGrp="1"/>
+          </p:cNvSpPr>
+          <p:nvPr>
+            <p:ph type="title"/>
+          </p:nvPr>
+        </p:nvSpPr>
+        <p:spPr/>
+        <p:txBody>
+          <a:bodyPr/>
+          <a:lstStyle/>
+          <a:p>
+            <a:r>
+              <a:rPr lang="en-US" dirty="0"/>
+              <a:t>Debugging an undebuggable Pod</a:t>
+            </a:r>
+          </a:p>
+        </p:txBody>
+      </p:sp>
+      <p:sp>
+        <p:nvSpPr>
+          <p:cNvPr id="3" name="TextBox 2">
+            <a:extLst>
+              <a:ext uri="{FF2B5EF4-FFF2-40B4-BE49-F238E27FC236}">
+                <a16:creationId xmlns:a16="http://schemas.microsoft.com/office/drawing/2014/main" id="{CDA4960A-C3A7-4291-ACBE-5CC735D7640F}"/>
+              </a:ext>
+            </a:extLst>
+          </p:cNvPr>
+          <p:cNvSpPr txBox="1"/>
+          <p:nvPr/>
+        </p:nvSpPr>
+        <p:spPr>
+          <a:xfrm>
+            <a:off x="504001" y="1544252"/>
+            <a:ext cx="10650031" cy="738664"/>
+          </a:xfrm>
+          <a:prstGeom prst="rect">
+            <a:avLst/>
+          </a:prstGeom>
+          <a:noFill/>
+        </p:spPr>
+        <p:txBody>
+          <a:bodyPr wrap="square" lIns="0" tIns="0" rIns="0" bIns="0" rtlCol="0">
+            <a:spAutoFit/>
+          </a:bodyPr>
+          <a:lstStyle/>
+          <a:p>
+            <a:pPr fontAlgn="base">
+              <a:spcBef>
+                <a:spcPct val="50000"/>
+              </a:spcBef>
+              <a:spcAft>
+                <a:spcPct val="0"/>
+              </a:spcAft>
+              <a:buClr>
+                <a:srgbClr val="F0AB00"/>
+              </a:buClr>
+              <a:buSzPct val="80000"/>
+            </a:pPr>
+            <a:r>
+              <a:rPr lang="en-US" sz="2400" b="1" kern="0" dirty="0" err="1">
+                <a:solidFill>
+                  <a:schemeClr val="accent1">
+                    <a:lumMod val="75000"/>
+                  </a:schemeClr>
+                </a:solidFill>
+                <a:latin typeface="Courier New" panose="02070309020205020404" pitchFamily="49" charset="0"/>
+                <a:ea typeface="Arial Unicode MS" pitchFamily="34" charset="-128"/>
+                <a:cs typeface="Courier New" panose="02070309020205020404" pitchFamily="49" charset="0"/>
+              </a:rPr>
+              <a:t>kubectl</a:t>
+            </a:r>
+            <a:r>
+              <a:rPr lang="en-US" sz="2400" b="1" kern="0" dirty="0">
+                <a:solidFill>
+                  <a:schemeClr val="accent1">
+                    <a:lumMod val="75000"/>
+                  </a:schemeClr>
+                </a:solidFill>
+                <a:latin typeface="Courier New" panose="02070309020205020404" pitchFamily="49" charset="0"/>
+                <a:ea typeface="Arial Unicode MS" pitchFamily="34" charset="-128"/>
+                <a:cs typeface="Courier New" panose="02070309020205020404" pitchFamily="49" charset="0"/>
+              </a:rPr>
+              <a:t> debug -it &lt;pod name&gt; --image=</a:t>
+            </a:r>
+            <a:r>
+              <a:rPr lang="en-US" sz="2400" b="1" kern="0" dirty="0" err="1">
+                <a:solidFill>
+                  <a:schemeClr val="accent1">
+                    <a:lumMod val="75000"/>
+                  </a:schemeClr>
+                </a:solidFill>
+                <a:latin typeface="Courier New" panose="02070309020205020404" pitchFamily="49" charset="0"/>
+                <a:ea typeface="Arial Unicode MS" pitchFamily="34" charset="-128"/>
+                <a:cs typeface="Courier New" panose="02070309020205020404" pitchFamily="49" charset="0"/>
+              </a:rPr>
+              <a:t>busybox</a:t>
+            </a:r>
+            <a:r>
+              <a:rPr lang="en-US" sz="2400" b="1" kern="0" dirty="0">
+                <a:solidFill>
+                  <a:schemeClr val="accent1">
+                    <a:lumMod val="75000"/>
+                  </a:schemeClr>
+                </a:solidFill>
+                <a:latin typeface="Courier New" panose="02070309020205020404" pitchFamily="49" charset="0"/>
+                <a:ea typeface="Arial Unicode MS" pitchFamily="34" charset="-128"/>
+                <a:cs typeface="Courier New" panose="02070309020205020404" pitchFamily="49" charset="0"/>
+              </a:rPr>
+              <a:t> </a:t>
+            </a:r>
+            <a:br>
+              <a:rPr lang="en-US" sz="2400" b="1" kern="0" dirty="0">
+                <a:solidFill>
+                  <a:schemeClr val="accent1">
+                    <a:lumMod val="75000"/>
+                  </a:schemeClr>
+                </a:solidFill>
+                <a:latin typeface="Courier New" panose="02070309020205020404" pitchFamily="49" charset="0"/>
+                <a:ea typeface="Arial Unicode MS" pitchFamily="34" charset="-128"/>
+                <a:cs typeface="Courier New" panose="02070309020205020404" pitchFamily="49" charset="0"/>
+              </a:rPr>
+            </a:br>
+            <a:r>
+              <a:rPr lang="en-US" sz="2400" b="1" kern="0" dirty="0">
+                <a:solidFill>
+                  <a:schemeClr val="accent1">
+                    <a:lumMod val="75000"/>
+                  </a:schemeClr>
+                </a:solidFill>
+                <a:latin typeface="Courier New" panose="02070309020205020404" pitchFamily="49" charset="0"/>
+                <a:ea typeface="Arial Unicode MS" pitchFamily="34" charset="-128"/>
+                <a:cs typeface="Courier New" panose="02070309020205020404" pitchFamily="49" charset="0"/>
+              </a:rPr>
+              <a:t>	</a:t>
+            </a:r>
+            <a:r>
+              <a:rPr lang="en-US" sz="2400" b="1" kern="0" dirty="0">
+                <a:solidFill>
+                  <a:schemeClr val="accent5">
+                    <a:lumMod val="75000"/>
+                  </a:schemeClr>
+                </a:solidFill>
+                <a:latin typeface="Courier New" panose="02070309020205020404" pitchFamily="49" charset="0"/>
+                <a:ea typeface="Arial Unicode MS" pitchFamily="34" charset="-128"/>
+                <a:cs typeface="Courier New" panose="02070309020205020404" pitchFamily="49" charset="0"/>
+              </a:rPr>
+              <a:t>--target=&lt;container name&gt;</a:t>
+            </a:r>
+          </a:p>
+        </p:txBody>
+      </p:sp>
+      <p:sp>
+        <p:nvSpPr>
+          <p:cNvPr id="9" name="Speech Bubble: Rectangle 8">
+            <a:extLst>
+              <a:ext uri="{FF2B5EF4-FFF2-40B4-BE49-F238E27FC236}">
+                <a16:creationId xmlns:a16="http://schemas.microsoft.com/office/drawing/2014/main" id="{24B68F1A-191A-4DAB-8767-E74884DAAADE}"/>
+              </a:ext>
+            </a:extLst>
+          </p:cNvPr>
+          <p:cNvSpPr/>
+          <p:nvPr/>
+        </p:nvSpPr>
+        <p:spPr bwMode="gray">
+          <a:xfrm>
+            <a:off x="7422292" y="2418363"/>
+            <a:ext cx="3909323" cy="977097"/>
+          </a:xfrm>
+          <a:prstGeom prst="wedgeRectCallout">
+            <a:avLst>
+              <a:gd name="adj1" fmla="val -33988"/>
+              <a:gd name="adj2" fmla="val -93689"/>
+            </a:avLst>
+          </a:prstGeom>
+          <a:ln>
+            <a:headEnd/>
+            <a:tailEnd/>
+          </a:ln>
+        </p:spPr>
+        <p:style>
+          <a:lnRef idx="2">
+            <a:schemeClr val="accent5"/>
+          </a:lnRef>
+          <a:fillRef idx="1">
+            <a:schemeClr val="lt1"/>
+          </a:fillRef>
+          <a:effectRef idx="0">
+            <a:schemeClr val="accent5"/>
+          </a:effectRef>
+          <a:fontRef idx="minor">
+            <a:schemeClr val="dk1"/>
+          </a:fontRef>
+        </p:style>
+        <p:txBody>
+          <a:bodyPr lIns="90000" tIns="72000" rIns="90000" bIns="72000" rtlCol="0" anchor="ctr"/>
+          <a:lstStyle/>
+          <a:p>
+            <a:pPr marR="0" algn="ctr" defTabSz="914400" eaLnBrk="1" fontAlgn="base" latinLnBrk="0" hangingPunct="1">
+              <a:lnSpc>
+                <a:spcPct val="100000"/>
+              </a:lnSpc>
+              <a:spcBef>
+                <a:spcPct val="50000"/>
+              </a:spcBef>
+              <a:spcAft>
+                <a:spcPct val="0"/>
+              </a:spcAft>
+              <a:buClr>
+                <a:srgbClr val="F0AB00"/>
+              </a:buClr>
+              <a:buSzPct val="80000"/>
+              <a:tabLst/>
+            </a:pPr>
+            <a:r>
+              <a:rPr lang="en-US" sz="1800" kern="0" dirty="0">
+                <a:ea typeface="Arial Unicode MS" pitchFamily="34" charset="-128"/>
+                <a:cs typeface="Arial Unicode MS" pitchFamily="34" charset="-128"/>
+              </a:rPr>
+              <a:t>Start an ephemeral container in a Pod and connects to its console</a:t>
+            </a:r>
+            <a:endParaRPr kumimoji="0" lang="en-US" sz="1800" b="0" i="0" u="none" strike="noStrike" kern="0" cap="none" spc="0" normalizeH="0" baseline="0" noProof="0" dirty="0">
+              <a:ln>
+                <a:noFill/>
+              </a:ln>
+              <a:effectLst/>
+              <a:uLnTx/>
+              <a:uFillTx/>
+              <a:ea typeface="Arial Unicode MS" pitchFamily="34" charset="-128"/>
+              <a:cs typeface="Arial Unicode MS" pitchFamily="34" charset="-128"/>
+            </a:endParaRPr>
+          </a:p>
+        </p:txBody>
+      </p:sp>
+      <p:sp>
+        <p:nvSpPr>
+          <p:cNvPr id="10" name="TextBox 9">
+            <a:extLst>
+              <a:ext uri="{FF2B5EF4-FFF2-40B4-BE49-F238E27FC236}">
+                <a16:creationId xmlns:a16="http://schemas.microsoft.com/office/drawing/2014/main" id="{431597A8-0A79-49E9-90E0-E616041139D4}"/>
+              </a:ext>
+            </a:extLst>
+          </p:cNvPr>
+          <p:cNvSpPr txBox="1"/>
+          <p:nvPr/>
+        </p:nvSpPr>
+        <p:spPr>
+          <a:xfrm>
+            <a:off x="504001" y="4145737"/>
+            <a:ext cx="11186476" cy="738664"/>
+          </a:xfrm>
+          <a:prstGeom prst="rect">
+            <a:avLst/>
+          </a:prstGeom>
+          <a:noFill/>
+        </p:spPr>
+        <p:txBody>
+          <a:bodyPr wrap="square" lIns="0" tIns="0" rIns="0" bIns="0" rtlCol="0">
+            <a:spAutoFit/>
+          </a:bodyPr>
+          <a:lstStyle/>
+          <a:p>
+            <a:pPr fontAlgn="base">
+              <a:spcBef>
+                <a:spcPct val="50000"/>
+              </a:spcBef>
+              <a:spcAft>
+                <a:spcPct val="0"/>
+              </a:spcAft>
+              <a:buClr>
+                <a:srgbClr val="F0AB00"/>
+              </a:buClr>
+              <a:buSzPct val="80000"/>
+            </a:pPr>
+            <a:r>
+              <a:rPr lang="en-US" sz="2400" b="1" kern="0" dirty="0" err="1">
+                <a:solidFill>
+                  <a:schemeClr val="accent1">
+                    <a:lumMod val="75000"/>
+                  </a:schemeClr>
+                </a:solidFill>
+                <a:latin typeface="Courier New" panose="02070309020205020404" pitchFamily="49" charset="0"/>
+                <a:ea typeface="Arial Unicode MS" pitchFamily="34" charset="-128"/>
+                <a:cs typeface="Courier New" panose="02070309020205020404" pitchFamily="49" charset="0"/>
+              </a:rPr>
+              <a:t>kubectl</a:t>
+            </a:r>
+            <a:r>
+              <a:rPr lang="en-US" sz="2400" b="1" kern="0" dirty="0">
+                <a:solidFill>
+                  <a:schemeClr val="accent1">
+                    <a:lumMod val="75000"/>
+                  </a:schemeClr>
+                </a:solidFill>
+                <a:latin typeface="Courier New" panose="02070309020205020404" pitchFamily="49" charset="0"/>
+                <a:ea typeface="Arial Unicode MS" pitchFamily="34" charset="-128"/>
+                <a:cs typeface="Courier New" panose="02070309020205020404" pitchFamily="49" charset="0"/>
+              </a:rPr>
+              <a:t> debug &lt;pod name&gt; -it --image=ubuntu </a:t>
+            </a:r>
+            <a:r>
+              <a:rPr lang="en-US" sz="2400" b="1" kern="0" dirty="0">
+                <a:solidFill>
+                  <a:schemeClr val="accent5">
+                    <a:lumMod val="75000"/>
+                  </a:schemeClr>
+                </a:solidFill>
+                <a:latin typeface="Courier New" panose="02070309020205020404" pitchFamily="49" charset="0"/>
+                <a:ea typeface="Arial Unicode MS" pitchFamily="34" charset="-128"/>
+                <a:cs typeface="Courier New" panose="02070309020205020404" pitchFamily="49" charset="0"/>
+              </a:rPr>
+              <a:t>--share-processes</a:t>
+            </a:r>
+            <a:br>
+              <a:rPr lang="en-US" sz="2400" b="1" kern="0" dirty="0">
+                <a:solidFill>
+                  <a:schemeClr val="accent1">
+                    <a:lumMod val="75000"/>
+                  </a:schemeClr>
+                </a:solidFill>
+                <a:latin typeface="Courier New" panose="02070309020205020404" pitchFamily="49" charset="0"/>
+                <a:ea typeface="Arial Unicode MS" pitchFamily="34" charset="-128"/>
+                <a:cs typeface="Courier New" panose="02070309020205020404" pitchFamily="49" charset="0"/>
+              </a:rPr>
+            </a:br>
+            <a:r>
+              <a:rPr lang="en-US" sz="2400" b="1" kern="0" dirty="0">
+                <a:solidFill>
+                  <a:schemeClr val="accent1">
+                    <a:lumMod val="75000"/>
+                  </a:schemeClr>
+                </a:solidFill>
+                <a:latin typeface="Courier New" panose="02070309020205020404" pitchFamily="49" charset="0"/>
+                <a:ea typeface="Arial Unicode MS" pitchFamily="34" charset="-128"/>
+                <a:cs typeface="Courier New" panose="02070309020205020404" pitchFamily="49" charset="0"/>
+              </a:rPr>
+              <a:t>	--copy-to=&lt;debug pod name&gt;</a:t>
+            </a:r>
+          </a:p>
+        </p:txBody>
+      </p:sp>
+      <p:sp>
+        <p:nvSpPr>
+          <p:cNvPr id="11" name="Speech Bubble: Rectangle 10">
+            <a:extLst>
+              <a:ext uri="{FF2B5EF4-FFF2-40B4-BE49-F238E27FC236}">
+                <a16:creationId xmlns:a16="http://schemas.microsoft.com/office/drawing/2014/main" id="{3C43FA7C-ED1E-4C21-9BB4-440FE4791F4B}"/>
+              </a:ext>
+            </a:extLst>
+          </p:cNvPr>
+          <p:cNvSpPr/>
+          <p:nvPr/>
+        </p:nvSpPr>
+        <p:spPr bwMode="gray">
+          <a:xfrm>
+            <a:off x="3086658" y="5283263"/>
+            <a:ext cx="5023962" cy="851528"/>
+          </a:xfrm>
+          <a:prstGeom prst="wedgeRectCallout">
+            <a:avLst>
+              <a:gd name="adj1" fmla="val -25561"/>
+              <a:gd name="adj2" fmla="val -88700"/>
+            </a:avLst>
+          </a:prstGeom>
+          <a:ln>
+            <a:headEnd/>
+            <a:tailEnd/>
+          </a:ln>
+        </p:spPr>
+        <p:style>
+          <a:lnRef idx="2">
+            <a:schemeClr val="accent5"/>
+          </a:lnRef>
+          <a:fillRef idx="1">
+            <a:schemeClr val="lt1"/>
+          </a:fillRef>
+          <a:effectRef idx="0">
+            <a:schemeClr val="accent5"/>
+          </a:effectRef>
+          <a:fontRef idx="minor">
+            <a:schemeClr val="dk1"/>
+          </a:fontRef>
+        </p:style>
+        <p:txBody>
+          <a:bodyPr lIns="90000" tIns="72000" rIns="90000" bIns="72000" rtlCol="0" anchor="ctr"/>
+          <a:lstStyle/>
+          <a:p>
+            <a:pPr marR="0" algn="ctr" defTabSz="914400" eaLnBrk="1" fontAlgn="base" latinLnBrk="0" hangingPunct="1">
+              <a:lnSpc>
+                <a:spcPct val="100000"/>
+              </a:lnSpc>
+              <a:spcBef>
+                <a:spcPct val="50000"/>
+              </a:spcBef>
+              <a:spcAft>
+                <a:spcPct val="0"/>
+              </a:spcAft>
+              <a:buClr>
+                <a:srgbClr val="F0AB00"/>
+              </a:buClr>
+              <a:buSzPct val="80000"/>
+              <a:tabLst/>
+            </a:pPr>
+            <a:r>
+              <a:rPr lang="en-US" sz="1800" kern="0" dirty="0">
+                <a:ea typeface="Arial Unicode MS" pitchFamily="34" charset="-128"/>
+                <a:cs typeface="Arial Unicode MS" pitchFamily="34" charset="-128"/>
+              </a:rPr>
+              <a:t>Create a copy of a Pod and add a container to it for debugging</a:t>
+            </a:r>
+            <a:endParaRPr kumimoji="0" lang="en-US" sz="1800" b="0" i="0" u="none" strike="noStrike" kern="0" cap="none" spc="0" normalizeH="0" baseline="0" noProof="0" dirty="0">
+              <a:ln>
+                <a:noFill/>
+              </a:ln>
+              <a:effectLst/>
+              <a:uLnTx/>
+              <a:uFillTx/>
+              <a:ea typeface="Arial Unicode MS" pitchFamily="34" charset="-128"/>
+              <a:cs typeface="Arial Unicode MS" pitchFamily="34" charset="-128"/>
+            </a:endParaRPr>
+          </a:p>
+        </p:txBody>
+      </p:sp>
+      <p:sp>
+        <p:nvSpPr>
+          <p:cNvPr id="12" name="Speech Bubble: Rectangle 11">
+            <a:extLst>
+              <a:ext uri="{FF2B5EF4-FFF2-40B4-BE49-F238E27FC236}">
+                <a16:creationId xmlns:a16="http://schemas.microsoft.com/office/drawing/2014/main" id="{BA962CA5-EAB1-4102-A020-FE941EBC16F8}"/>
+              </a:ext>
+            </a:extLst>
+          </p:cNvPr>
+          <p:cNvSpPr/>
+          <p:nvPr/>
+        </p:nvSpPr>
+        <p:spPr bwMode="gray">
+          <a:xfrm>
+            <a:off x="646669" y="2668705"/>
+            <a:ext cx="4057135" cy="977097"/>
+          </a:xfrm>
+          <a:prstGeom prst="wedgeRectCallout">
+            <a:avLst>
+              <a:gd name="adj1" fmla="val 46571"/>
+              <a:gd name="adj2" fmla="val -85258"/>
+            </a:avLst>
+          </a:prstGeom>
+          <a:ln>
+            <a:headEnd/>
+            <a:tailEnd/>
+          </a:ln>
+        </p:spPr>
+        <p:style>
+          <a:lnRef idx="2">
+            <a:schemeClr val="accent1"/>
+          </a:lnRef>
+          <a:fillRef idx="1">
+            <a:schemeClr val="lt1"/>
+          </a:fillRef>
+          <a:effectRef idx="0">
+            <a:schemeClr val="accent1"/>
+          </a:effectRef>
+          <a:fontRef idx="minor">
+            <a:schemeClr val="dk1"/>
+          </a:fontRef>
+        </p:style>
+        <p:txBody>
+          <a:bodyPr lIns="90000" tIns="72000" rIns="90000" bIns="72000" rtlCol="0" anchor="ctr"/>
+          <a:lstStyle/>
+          <a:p>
+            <a:pPr marR="0" algn="ctr" defTabSz="914400" eaLnBrk="1" fontAlgn="base" latinLnBrk="0" hangingPunct="1">
+              <a:lnSpc>
+                <a:spcPct val="100000"/>
+              </a:lnSpc>
+              <a:spcBef>
+                <a:spcPct val="50000"/>
+              </a:spcBef>
+              <a:spcAft>
+                <a:spcPct val="0"/>
+              </a:spcAft>
+              <a:buClr>
+                <a:srgbClr val="F0AB00"/>
+              </a:buClr>
+              <a:buSzPct val="80000"/>
+              <a:tabLst/>
+            </a:pPr>
+            <a:r>
+              <a:rPr lang="en-US" sz="1800" kern="0" dirty="0">
+                <a:ea typeface="Arial Unicode MS" pitchFamily="34" charset="-128"/>
+                <a:cs typeface="Arial Unicode MS" pitchFamily="34" charset="-128"/>
+              </a:rPr>
+              <a:t>Ephemeral container connects to process namespace of this container</a:t>
+            </a:r>
+            <a:endParaRPr kumimoji="0" lang="en-US" sz="1800" b="0" i="0" u="none" strike="noStrike" kern="0" cap="none" spc="0" normalizeH="0" baseline="0" noProof="0" dirty="0">
+              <a:ln>
+                <a:noFill/>
+              </a:ln>
+              <a:effectLst/>
+              <a:uLnTx/>
+              <a:uFillTx/>
+              <a:ea typeface="Arial Unicode MS" pitchFamily="34" charset="-128"/>
+              <a:cs typeface="Arial Unicode MS" pitchFamily="34" charset="-128"/>
+            </a:endParaRPr>
+          </a:p>
+        </p:txBody>
+      </p:sp>
+    </p:spTree>
+    <p:extLst>
+      <p:ext uri="{BB962C8B-B14F-4D97-AF65-F5344CB8AC3E}">
+        <p14:creationId xmlns:p14="http://schemas.microsoft.com/office/powerpoint/2010/main" val="2285465406"/>
+      </p:ext>
+    </p:extLst>
+  </p:cSld>
+  <p:clrMapOvr>
+    <a:masterClrMapping/>
+  </p:clrMapOvr>
+</p:sld>
+</file>
+
+<file path=ppt/slides/slide8.xml><?xml version="1.0" encoding="utf-8"?>
+<p:sld xmlns:a="http://schemas.openxmlformats.org/drawingml/2006/main" xmlns:r="http://schemas.openxmlformats.org/officeDocument/2006/relationships" xmlns:p="http://schemas.openxmlformats.org/presentationml/2006/main">
+  <p:cSld>
+    <p:spTree>
+      <p:nvGrpSpPr>
+        <p:cNvPr id="1" name=""/>
+        <p:cNvGrpSpPr/>
+        <p:nvPr/>
+      </p:nvGrpSpPr>
+      <p:grpSpPr>
+        <a:xfrm>
+          <a:off x="0" y="0"/>
+          <a:ext cx="0" cy="0"/>
+          <a:chOff x="0" y="0"/>
+          <a:chExt cx="0" cy="0"/>
+        </a:xfrm>
+      </p:grpSpPr>
+      <p:sp>
+        <p:nvSpPr>
           <p:cNvPr id="3" name="Title 2"/>
           <p:cNvSpPr>
             <a:spLocks noGrp="1"/>
@@ -17856,7 +19156,7 @@
 </p:sld>
 </file>
 
-<file path=ppt/slides/slide8.xml><?xml version="1.0" encoding="utf-8"?>
+<file path=ppt/slides/slide9.xml><?xml version="1.0" encoding="utf-8"?>
 <p:sld xmlns:a="http://schemas.openxmlformats.org/drawingml/2006/main" xmlns:r="http://schemas.openxmlformats.org/officeDocument/2006/relationships" xmlns:p="http://schemas.openxmlformats.org/presentationml/2006/main">
   <p:cSld>
     <p:spTree>
@@ -18384,542 +19684,6 @@
     <p:extLst>
       <p:ext uri="{BB962C8B-B14F-4D97-AF65-F5344CB8AC3E}">
         <p14:creationId xmlns:p14="http://schemas.microsoft.com/office/powerpoint/2010/main" val="2933799799"/>
-      </p:ext>
-    </p:extLst>
-  </p:cSld>
-  <p:clrMapOvr>
-    <a:masterClrMapping/>
-  </p:clrMapOvr>
-</p:sld>
-</file>
-
-<file path=ppt/slides/slide9.xml><?xml version="1.0" encoding="utf-8"?>
-<p:sld xmlns:a="http://schemas.openxmlformats.org/drawingml/2006/main" xmlns:r="http://schemas.openxmlformats.org/officeDocument/2006/relationships" xmlns:p="http://schemas.openxmlformats.org/presentationml/2006/main">
-  <p:cSld>
-    <p:spTree>
-      <p:nvGrpSpPr>
-        <p:cNvPr id="1" name=""/>
-        <p:cNvGrpSpPr/>
-        <p:nvPr/>
-      </p:nvGrpSpPr>
-      <p:grpSpPr>
-        <a:xfrm>
-          <a:off x="0" y="0"/>
-          <a:ext cx="0" cy="0"/>
-          <a:chOff x="0" y="0"/>
-          <a:chExt cx="0" cy="0"/>
-        </a:xfrm>
-      </p:grpSpPr>
-      <p:sp>
-        <p:nvSpPr>
-          <p:cNvPr id="2" name="Title 1">
-            <a:extLst>
-              <a:ext uri="{FF2B5EF4-FFF2-40B4-BE49-F238E27FC236}">
-                <a16:creationId xmlns:a16="http://schemas.microsoft.com/office/drawing/2014/main" id="{B5CAB707-1225-4D64-A95E-F1193D92F3BE}"/>
-              </a:ext>
-            </a:extLst>
-          </p:cNvPr>
-          <p:cNvSpPr>
-            <a:spLocks noGrp="1"/>
-          </p:cNvSpPr>
-          <p:nvPr>
-            <p:ph type="title"/>
-          </p:nvPr>
-        </p:nvSpPr>
-        <p:spPr/>
-        <p:txBody>
-          <a:bodyPr/>
-          <a:lstStyle/>
-          <a:p>
-            <a:r>
-              <a:rPr lang="en-US" dirty="0"/>
-              <a:t>Issues with services</a:t>
-            </a:r>
-          </a:p>
-        </p:txBody>
-      </p:sp>
-      <p:sp>
-        <p:nvSpPr>
-          <p:cNvPr id="3" name="Rectangle 2">
-            <a:extLst>
-              <a:ext uri="{FF2B5EF4-FFF2-40B4-BE49-F238E27FC236}">
-                <a16:creationId xmlns:a16="http://schemas.microsoft.com/office/drawing/2014/main" id="{B6791FF6-F4CE-4E9F-BD65-77201830485B}"/>
-              </a:ext>
-            </a:extLst>
-          </p:cNvPr>
-          <p:cNvSpPr/>
-          <p:nvPr/>
-        </p:nvSpPr>
-        <p:spPr>
-          <a:xfrm>
-            <a:off x="504001" y="6021077"/>
-            <a:ext cx="9606354" cy="415498"/>
-          </a:xfrm>
-          <a:prstGeom prst="rect">
-            <a:avLst/>
-          </a:prstGeom>
-        </p:spPr>
-        <p:txBody>
-          <a:bodyPr wrap="square">
-            <a:spAutoFit/>
-          </a:bodyPr>
-          <a:lstStyle/>
-          <a:p>
-            <a:r>
-              <a:rPr lang="en-US" dirty="0">
-                <a:hlinkClick r:id="rId3"/>
-              </a:rPr>
-              <a:t>https://kubernetes.io/docs/tasks/debug-application-cluster/debug-service/</a:t>
-            </a:r>
-            <a:r>
-              <a:rPr lang="en-US" dirty="0"/>
-              <a:t> </a:t>
-            </a:r>
-          </a:p>
-        </p:txBody>
-      </p:sp>
-      <p:sp>
-        <p:nvSpPr>
-          <p:cNvPr id="4" name="Rectangle 3">
-            <a:extLst>
-              <a:ext uri="{FF2B5EF4-FFF2-40B4-BE49-F238E27FC236}">
-                <a16:creationId xmlns:a16="http://schemas.microsoft.com/office/drawing/2014/main" id="{8EA39D1E-A943-46DB-91C6-E6352F757421}"/>
-              </a:ext>
-            </a:extLst>
-          </p:cNvPr>
-          <p:cNvSpPr/>
-          <p:nvPr/>
-        </p:nvSpPr>
-        <p:spPr>
-          <a:xfrm>
-            <a:off x="504000" y="1345168"/>
-            <a:ext cx="9751827" cy="4524315"/>
-          </a:xfrm>
-          <a:prstGeom prst="rect">
-            <a:avLst/>
-          </a:prstGeom>
-        </p:spPr>
-        <p:txBody>
-          <a:bodyPr wrap="square">
-            <a:spAutoFit/>
-          </a:bodyPr>
-          <a:lstStyle/>
-          <a:p>
-            <a:r>
-              <a:rPr lang="en-US" sz="2400" b="1" kern="0" dirty="0" err="1">
-                <a:solidFill>
-                  <a:schemeClr val="accent1">
-                    <a:lumMod val="75000"/>
-                  </a:schemeClr>
-                </a:solidFill>
-                <a:latin typeface="Courier New" panose="02070309020205020404" pitchFamily="49" charset="0"/>
-                <a:ea typeface="Arial Unicode MS" pitchFamily="34" charset="-128"/>
-                <a:cs typeface="Courier New" panose="02070309020205020404" pitchFamily="49" charset="0"/>
-              </a:rPr>
-              <a:t>kubectl</a:t>
-            </a:r>
-            <a:r>
-              <a:rPr lang="en-US" sz="2400" b="1" kern="0" dirty="0">
-                <a:solidFill>
-                  <a:schemeClr val="accent1">
-                    <a:lumMod val="75000"/>
-                  </a:schemeClr>
-                </a:solidFill>
-                <a:latin typeface="Courier New" panose="02070309020205020404" pitchFamily="49" charset="0"/>
-                <a:ea typeface="Arial Unicode MS" pitchFamily="34" charset="-128"/>
-                <a:cs typeface="Courier New" panose="02070309020205020404" pitchFamily="49" charset="0"/>
-              </a:rPr>
-              <a:t> -n </a:t>
-            </a:r>
-            <a:r>
-              <a:rPr lang="en-US" sz="2400" b="1" kern="0" dirty="0" err="1">
-                <a:solidFill>
-                  <a:schemeClr val="accent1">
-                    <a:lumMod val="75000"/>
-                  </a:schemeClr>
-                </a:solidFill>
-                <a:latin typeface="Courier New" panose="02070309020205020404" pitchFamily="49" charset="0"/>
-                <a:ea typeface="Arial Unicode MS" pitchFamily="34" charset="-128"/>
-                <a:cs typeface="Courier New" panose="02070309020205020404" pitchFamily="49" charset="0"/>
-              </a:rPr>
-              <a:t>kube</a:t>
-            </a:r>
-            <a:r>
-              <a:rPr lang="en-US" sz="2400" b="1" kern="0" dirty="0">
-                <a:solidFill>
-                  <a:schemeClr val="accent1">
-                    <a:lumMod val="75000"/>
-                  </a:schemeClr>
-                </a:solidFill>
-                <a:latin typeface="Courier New" panose="02070309020205020404" pitchFamily="49" charset="0"/>
-                <a:ea typeface="Arial Unicode MS" pitchFamily="34" charset="-128"/>
-                <a:cs typeface="Courier New" panose="02070309020205020404" pitchFamily="49" charset="0"/>
-              </a:rPr>
-              <a:t>-system describe svc node-exporter</a:t>
-            </a:r>
-          </a:p>
-          <a:p>
-            <a:endParaRPr lang="en-US" sz="2400" b="1" kern="0" dirty="0">
-              <a:latin typeface="Courier New" panose="02070309020205020404" pitchFamily="49" charset="0"/>
-              <a:ea typeface="Arial Unicode MS" pitchFamily="34" charset="-128"/>
-              <a:cs typeface="Courier New" panose="02070309020205020404" pitchFamily="49" charset="0"/>
-            </a:endParaRPr>
-          </a:p>
-          <a:p>
-            <a:r>
-              <a:rPr lang="en-US" sz="2400" b="1" kern="0" dirty="0">
-                <a:latin typeface="Courier New" panose="02070309020205020404" pitchFamily="49" charset="0"/>
-                <a:ea typeface="Arial Unicode MS" pitchFamily="34" charset="-128"/>
-                <a:cs typeface="Courier New" panose="02070309020205020404" pitchFamily="49" charset="0"/>
-              </a:rPr>
-              <a:t>…</a:t>
-            </a:r>
-          </a:p>
-          <a:p>
-            <a:r>
-              <a:rPr lang="en-US" sz="2400" b="1" kern="0" dirty="0">
-                <a:latin typeface="Courier New" panose="02070309020205020404" pitchFamily="49" charset="0"/>
-                <a:ea typeface="Arial Unicode MS" pitchFamily="34" charset="-128"/>
-                <a:cs typeface="Courier New" panose="02070309020205020404" pitchFamily="49" charset="0"/>
-              </a:rPr>
-              <a:t>Selector:          component=node-exporter</a:t>
-            </a:r>
-          </a:p>
-          <a:p>
-            <a:r>
-              <a:rPr lang="en-US" sz="2400" b="1" kern="0" dirty="0">
-                <a:latin typeface="Courier New" panose="02070309020205020404" pitchFamily="49" charset="0"/>
-                <a:ea typeface="Arial Unicode MS" pitchFamily="34" charset="-128"/>
-                <a:cs typeface="Courier New" panose="02070309020205020404" pitchFamily="49" charset="0"/>
-              </a:rPr>
-              <a:t>Type:              </a:t>
-            </a:r>
-            <a:r>
-              <a:rPr lang="en-US" sz="2400" b="1" kern="0" dirty="0" err="1">
-                <a:latin typeface="Courier New" panose="02070309020205020404" pitchFamily="49" charset="0"/>
-                <a:ea typeface="Arial Unicode MS" pitchFamily="34" charset="-128"/>
-                <a:cs typeface="Courier New" panose="02070309020205020404" pitchFamily="49" charset="0"/>
-              </a:rPr>
-              <a:t>ClusterIP</a:t>
-            </a:r>
-            <a:endParaRPr lang="en-US" sz="2400" b="1" kern="0" dirty="0">
-              <a:latin typeface="Courier New" panose="02070309020205020404" pitchFamily="49" charset="0"/>
-              <a:ea typeface="Arial Unicode MS" pitchFamily="34" charset="-128"/>
-              <a:cs typeface="Courier New" panose="02070309020205020404" pitchFamily="49" charset="0"/>
-            </a:endParaRPr>
-          </a:p>
-          <a:p>
-            <a:r>
-              <a:rPr lang="en-US" sz="2400" b="1" kern="0" dirty="0">
-                <a:latin typeface="Courier New" panose="02070309020205020404" pitchFamily="49" charset="0"/>
-                <a:ea typeface="Arial Unicode MS" pitchFamily="34" charset="-128"/>
-                <a:cs typeface="Courier New" panose="02070309020205020404" pitchFamily="49" charset="0"/>
-              </a:rPr>
-              <a:t>IP:                None</a:t>
-            </a:r>
-          </a:p>
-          <a:p>
-            <a:r>
-              <a:rPr lang="en-US" sz="2400" b="1" kern="0" dirty="0">
-                <a:latin typeface="Courier New" panose="02070309020205020404" pitchFamily="49" charset="0"/>
-                <a:ea typeface="Arial Unicode MS" pitchFamily="34" charset="-128"/>
-                <a:cs typeface="Courier New" panose="02070309020205020404" pitchFamily="49" charset="0"/>
-              </a:rPr>
-              <a:t>Port:              metrics  9100/TCP</a:t>
-            </a:r>
-          </a:p>
-          <a:p>
-            <a:r>
-              <a:rPr lang="en-US" sz="2400" b="1" kern="0" dirty="0" err="1">
-                <a:latin typeface="Courier New" panose="02070309020205020404" pitchFamily="49" charset="0"/>
-                <a:ea typeface="Arial Unicode MS" pitchFamily="34" charset="-128"/>
-                <a:cs typeface="Courier New" panose="02070309020205020404" pitchFamily="49" charset="0"/>
-              </a:rPr>
-              <a:t>TargetPort</a:t>
-            </a:r>
-            <a:r>
-              <a:rPr lang="en-US" sz="2400" b="1" kern="0" dirty="0">
-                <a:latin typeface="Courier New" panose="02070309020205020404" pitchFamily="49" charset="0"/>
-                <a:ea typeface="Arial Unicode MS" pitchFamily="34" charset="-128"/>
-                <a:cs typeface="Courier New" panose="02070309020205020404" pitchFamily="49" charset="0"/>
-              </a:rPr>
-              <a:t>:        9100/TCP</a:t>
-            </a:r>
-          </a:p>
-          <a:p>
-            <a:r>
-              <a:rPr lang="en-US" sz="2400" b="1" kern="0" dirty="0">
-                <a:latin typeface="Courier New" panose="02070309020205020404" pitchFamily="49" charset="0"/>
-                <a:ea typeface="Arial Unicode MS" pitchFamily="34" charset="-128"/>
-                <a:cs typeface="Courier New" panose="02070309020205020404" pitchFamily="49" charset="0"/>
-              </a:rPr>
-              <a:t>Endpoints:            10.250.0.2:9100,10.250.0.3:9100,10.250.0.4:9100</a:t>
-            </a:r>
-          </a:p>
-          <a:p>
-            <a:r>
-              <a:rPr lang="en-US" sz="2400" b="1" kern="0" dirty="0">
-                <a:latin typeface="Courier New" panose="02070309020205020404" pitchFamily="49" charset="0"/>
-                <a:ea typeface="Arial Unicode MS" pitchFamily="34" charset="-128"/>
-                <a:cs typeface="Courier New" panose="02070309020205020404" pitchFamily="49" charset="0"/>
-              </a:rPr>
-              <a:t>Session Affinity:  None</a:t>
-            </a:r>
-          </a:p>
-          <a:p>
-            <a:r>
-              <a:rPr lang="en-US" sz="2400" b="1" kern="0" dirty="0">
-                <a:latin typeface="Courier New" panose="02070309020205020404" pitchFamily="49" charset="0"/>
-                <a:ea typeface="Arial Unicode MS" pitchFamily="34" charset="-128"/>
-                <a:cs typeface="Courier New" panose="02070309020205020404" pitchFamily="49" charset="0"/>
-              </a:rPr>
-              <a:t>Events:            &lt;none&gt;</a:t>
-            </a:r>
-          </a:p>
-        </p:txBody>
-      </p:sp>
-      <p:sp>
-        <p:nvSpPr>
-          <p:cNvPr id="5" name="Speech Bubble: Rectangle 4">
-            <a:extLst>
-              <a:ext uri="{FF2B5EF4-FFF2-40B4-BE49-F238E27FC236}">
-                <a16:creationId xmlns:a16="http://schemas.microsoft.com/office/drawing/2014/main" id="{39365804-9B3C-4E0D-AC45-AF4553A32332}"/>
-              </a:ext>
-            </a:extLst>
-          </p:cNvPr>
-          <p:cNvSpPr/>
-          <p:nvPr/>
-        </p:nvSpPr>
-        <p:spPr bwMode="gray">
-          <a:xfrm>
-            <a:off x="9023050" y="1838837"/>
-            <a:ext cx="2667427" cy="677425"/>
-          </a:xfrm>
-          <a:prstGeom prst="wedgeRectCallout">
-            <a:avLst>
-              <a:gd name="adj1" fmla="val -73263"/>
-              <a:gd name="adj2" fmla="val 64322"/>
-            </a:avLst>
-          </a:prstGeom>
-          <a:ln>
-            <a:headEnd/>
-            <a:tailEnd/>
-          </a:ln>
-        </p:spPr>
-        <p:style>
-          <a:lnRef idx="2">
-            <a:schemeClr val="accent5"/>
-          </a:lnRef>
-          <a:fillRef idx="1">
-            <a:schemeClr val="lt1"/>
-          </a:fillRef>
-          <a:effectRef idx="0">
-            <a:schemeClr val="accent5"/>
-          </a:effectRef>
-          <a:fontRef idx="minor">
-            <a:schemeClr val="dk1"/>
-          </a:fontRef>
-        </p:style>
-        <p:txBody>
-          <a:bodyPr lIns="90000" tIns="72000" rIns="90000" bIns="72000" rtlCol="0" anchor="ctr"/>
-          <a:lstStyle/>
-          <a:p>
-            <a:pPr marR="0" algn="ctr" defTabSz="914400" eaLnBrk="1" fontAlgn="base" latinLnBrk="0" hangingPunct="1">
-              <a:lnSpc>
-                <a:spcPct val="100000"/>
-              </a:lnSpc>
-              <a:spcBef>
-                <a:spcPct val="50000"/>
-              </a:spcBef>
-              <a:spcAft>
-                <a:spcPct val="0"/>
-              </a:spcAft>
-              <a:buClr>
-                <a:srgbClr val="F0AB00"/>
-              </a:buClr>
-              <a:buSzPct val="80000"/>
-              <a:tabLst/>
-            </a:pPr>
-            <a:r>
-              <a:rPr lang="en-US" sz="1800" kern="0" dirty="0">
-                <a:ea typeface="Arial Unicode MS" pitchFamily="34" charset="-128"/>
-                <a:cs typeface="Arial Unicode MS" pitchFamily="34" charset="-128"/>
-              </a:rPr>
-              <a:t>Correct labels?</a:t>
-            </a:r>
-            <a:endParaRPr kumimoji="0" lang="en-US" sz="1800" b="0" i="0" u="none" strike="noStrike" kern="0" cap="none" spc="0" normalizeH="0" baseline="0" noProof="0" dirty="0">
-              <a:ln>
-                <a:noFill/>
-              </a:ln>
-              <a:effectLst/>
-              <a:uLnTx/>
-              <a:uFillTx/>
-              <a:ea typeface="Arial Unicode MS" pitchFamily="34" charset="-128"/>
-              <a:cs typeface="Arial Unicode MS" pitchFamily="34" charset="-128"/>
-            </a:endParaRPr>
-          </a:p>
-        </p:txBody>
-      </p:sp>
-      <p:sp>
-        <p:nvSpPr>
-          <p:cNvPr id="6" name="Speech Bubble: Rectangle 5">
-            <a:extLst>
-              <a:ext uri="{FF2B5EF4-FFF2-40B4-BE49-F238E27FC236}">
-                <a16:creationId xmlns:a16="http://schemas.microsoft.com/office/drawing/2014/main" id="{B6BA9F4F-D22A-42EF-9C65-EBE3C7731785}"/>
-              </a:ext>
-            </a:extLst>
-          </p:cNvPr>
-          <p:cNvSpPr/>
-          <p:nvPr/>
-        </p:nvSpPr>
-        <p:spPr bwMode="gray">
-          <a:xfrm>
-            <a:off x="9023049" y="3268612"/>
-            <a:ext cx="2667427" cy="677425"/>
-          </a:xfrm>
-          <a:prstGeom prst="wedgeRectCallout">
-            <a:avLst>
-              <a:gd name="adj1" fmla="val -73263"/>
-              <a:gd name="adj2" fmla="val 64322"/>
-            </a:avLst>
-          </a:prstGeom>
-          <a:ln>
-            <a:headEnd/>
-            <a:tailEnd/>
-          </a:ln>
-        </p:spPr>
-        <p:style>
-          <a:lnRef idx="2">
-            <a:schemeClr val="accent5"/>
-          </a:lnRef>
-          <a:fillRef idx="1">
-            <a:schemeClr val="lt1"/>
-          </a:fillRef>
-          <a:effectRef idx="0">
-            <a:schemeClr val="accent5"/>
-          </a:effectRef>
-          <a:fontRef idx="minor">
-            <a:schemeClr val="dk1"/>
-          </a:fontRef>
-        </p:style>
-        <p:txBody>
-          <a:bodyPr lIns="90000" tIns="72000" rIns="90000" bIns="72000" rtlCol="0" anchor="ctr"/>
-          <a:lstStyle/>
-          <a:p>
-            <a:pPr marR="0" algn="ctr" defTabSz="914400" eaLnBrk="1" fontAlgn="base" latinLnBrk="0" hangingPunct="1">
-              <a:lnSpc>
-                <a:spcPct val="100000"/>
-              </a:lnSpc>
-              <a:spcBef>
-                <a:spcPct val="50000"/>
-              </a:spcBef>
-              <a:spcAft>
-                <a:spcPct val="0"/>
-              </a:spcAft>
-              <a:buClr>
-                <a:srgbClr val="F0AB00"/>
-              </a:buClr>
-              <a:buSzPct val="80000"/>
-              <a:tabLst/>
-            </a:pPr>
-            <a:r>
-              <a:rPr kumimoji="0" lang="en-US" sz="1800" b="0" i="0" u="none" strike="noStrike" kern="0" cap="none" spc="0" normalizeH="0" baseline="0" noProof="0" dirty="0">
-                <a:ln>
-                  <a:noFill/>
-                </a:ln>
-                <a:effectLst/>
-                <a:uLnTx/>
-                <a:uFillTx/>
-                <a:ea typeface="Arial Unicode MS" pitchFamily="34" charset="-128"/>
-                <a:cs typeface="Arial Unicode MS" pitchFamily="34" charset="-128"/>
-              </a:rPr>
-              <a:t>Correct target port of pods? </a:t>
-            </a:r>
-          </a:p>
-        </p:txBody>
-      </p:sp>
-      <p:sp>
-        <p:nvSpPr>
-          <p:cNvPr id="7" name="Speech Bubble: Rectangle 6">
-            <a:extLst>
-              <a:ext uri="{FF2B5EF4-FFF2-40B4-BE49-F238E27FC236}">
-                <a16:creationId xmlns:a16="http://schemas.microsoft.com/office/drawing/2014/main" id="{A18D8DEB-83CF-4D76-BC6D-2B1E52C31FBC}"/>
-              </a:ext>
-            </a:extLst>
-          </p:cNvPr>
-          <p:cNvSpPr/>
-          <p:nvPr/>
-        </p:nvSpPr>
-        <p:spPr bwMode="gray">
-          <a:xfrm>
-            <a:off x="9023049" y="5229520"/>
-            <a:ext cx="2667427" cy="677425"/>
-          </a:xfrm>
-          <a:prstGeom prst="wedgeRectCallout">
-            <a:avLst>
-              <a:gd name="adj1" fmla="val -75990"/>
-              <a:gd name="adj2" fmla="val -55321"/>
-            </a:avLst>
-          </a:prstGeom>
-          <a:ln>
-            <a:headEnd/>
-            <a:tailEnd/>
-          </a:ln>
-        </p:spPr>
-        <p:style>
-          <a:lnRef idx="2">
-            <a:schemeClr val="accent5"/>
-          </a:lnRef>
-          <a:fillRef idx="1">
-            <a:schemeClr val="lt1"/>
-          </a:fillRef>
-          <a:effectRef idx="0">
-            <a:schemeClr val="accent5"/>
-          </a:effectRef>
-          <a:fontRef idx="minor">
-            <a:schemeClr val="dk1"/>
-          </a:fontRef>
-        </p:style>
-        <p:txBody>
-          <a:bodyPr lIns="90000" tIns="72000" rIns="90000" bIns="72000" rtlCol="0" anchor="ctr"/>
-          <a:lstStyle/>
-          <a:p>
-            <a:pPr marR="0" algn="ctr" defTabSz="914400" eaLnBrk="1" fontAlgn="base" latinLnBrk="0" hangingPunct="1">
-              <a:lnSpc>
-                <a:spcPct val="100000"/>
-              </a:lnSpc>
-              <a:spcBef>
-                <a:spcPct val="50000"/>
-              </a:spcBef>
-              <a:spcAft>
-                <a:spcPct val="0"/>
-              </a:spcAft>
-              <a:buClr>
-                <a:srgbClr val="F0AB00"/>
-              </a:buClr>
-              <a:buSzPct val="80000"/>
-              <a:tabLst/>
-            </a:pPr>
-            <a:r>
-              <a:rPr kumimoji="0" lang="en-US" sz="1800" b="0" i="0" u="none" strike="noStrike" kern="0" cap="none" spc="0" normalizeH="0" baseline="0" noProof="0" dirty="0">
-                <a:ln>
-                  <a:noFill/>
-                </a:ln>
-                <a:effectLst/>
-                <a:uLnTx/>
-                <a:uFillTx/>
-                <a:ea typeface="Arial Unicode MS" pitchFamily="34" charset="-128"/>
-                <a:cs typeface="Arial Unicode MS" pitchFamily="34" charset="-128"/>
-              </a:rPr>
-              <a:t>Are any pods available?</a:t>
-            </a:r>
-          </a:p>
-        </p:txBody>
-      </p:sp>
-    </p:spTree>
-    <p:extLst>
-      <p:ext uri="{BB962C8B-B14F-4D97-AF65-F5344CB8AC3E}">
-        <p14:creationId xmlns:p14="http://schemas.microsoft.com/office/powerpoint/2010/main" val="1979287927"/>
       </p:ext>
     </p:extLst>
   </p:cSld>

</xml_diff>